<commit_message>
Rebuild deck with ML results
</commit_message>
<xml_diff>
--- a/presentation/Beyond40C_ProbStats.pptx
+++ b/presentation/Beyond40C_ProbStats.pptx
@@ -29,6 +29,9 @@
     <p:sldId id="277" r:id="rId29"/>
     <p:sldId id="278" r:id="rId30"/>
     <p:sldId id="279" r:id="rId31"/>
+    <p:sldId id="280" r:id="rId32"/>
+    <p:sldId id="281" r:id="rId33"/>
+    <p:sldId id="282" r:id="rId34"/>
   </p:sldIdLst>
   <p:sldSz cx="12191695" cy="6858000" type="screen4x3"/>
   <p:notesSz cx="6858000" cy="9144000"/>
@@ -1365,7 +1368,7 @@
           <a:lstStyle/>
           <a:p>
             <a:r>
-              <a:t>Everything is explorable in a Shiny dashboard. The risk calculator shows the problem in one screen: the IMD rule says no alert, while the wet-bulb is 30.7 °C and the model gives a 99% chance of a danger day tomorrow. Other tabs show each city's barcode of missed days, its trend, and its return levels.</a:t>
+              <a:t>RQ6 pushes the warning further with standard baseline machine-learning models: a decision tree and a random forest, next to the logistic model and climatology. We forecast one, two and three days ahead with the same unseen test years. Three things are new: features built from physiology, a hybrid alert that keeps the IMD rule and adds an ML layer, and a test of whether the model works in a city it was never trained on.</a:t>
             </a:r>
           </a:p>
         </p:txBody>
@@ -1435,7 +1438,7 @@
           <a:lstStyle/>
           <a:p>
             <a:r>
-              <a:t>To answer the five questions: the rule misses 96% of dangerous humid heat; danger days grow about 54% per decade; extremes are shifting in seven of ten cities; danger comes in persistent spells; and a simple calibrated model warns far better than the rule. Three recommendations follow.</a:t>
+              <a:t>On the unseen years the random forest is best at every lead time: AUC 0.95 one day ahead against 0.92 for logistic regression and 0.61 for the IMD rule, and still 0.89 three days ahead. A single decision tree is the weakest model; averaging many trees removes its variance. Our physiology-informed headroom feature ranks 5 of 24.</a:t>
             </a:r>
           </a:p>
         </p:txBody>
@@ -1505,7 +1508,7 @@
           <a:lstStyle/>
           <a:p>
             <a:r>
-              <a:t>Limitations. ERA5's 25 km grid smooths extremes, so station data would raise every count, but the dry-versus-humid separation is structural. Our one-cell rule flatters IMD. Physiological limits come from young, healthy adults. Next steps: station data, mortality or hospital data to validate thresholds, and a district-level operational forecast.</a:t>
+              <a:t>The hybrid alert keeps the IMD rule and adds the random-forest layer. It recovers 45% of the next-day danger days the IMD rule cannot see, against 1% for the rule alone. On the right, each city is held out completely: trained on the others, the forest still reaches a mean AUC of 0.93, almost the 0.94 it gets with local data. The cost is false alarms, which suits a cheap advisory such as hydrate-and-rest messaging.</a:t>
             </a:r>
           </a:p>
         </p:txBody>
@@ -1575,7 +1578,7 @@
           <a:lstStyle/>
           <a:p>
             <a:r>
-              <a:t>Key references.</a:t>
+              <a:t>Everything is explorable in a Shiny dashboard. The risk calculator shows the problem in one screen: the IMD rule says no alert, while the wet-bulb is 30.7 °C and the model gives a 99% chance of a danger day tomorrow. Other tabs show each city's barcode of missed days, its trend, and its return levels.</a:t>
             </a:r>
           </a:p>
         </p:txBody>
@@ -1645,6 +1648,216 @@
           <a:lstStyle/>
           <a:p>
             <a:r>
+              <a:t>To answer the six questions: the rule misses 96% of dangerous humid heat; danger days grow about 54% per decade; extremes are shifting in seven of ten cities; danger comes in persistent spells; a simple calibrated model warns far better than the rule; and a random forest extends the warning to three days and to cities with no history. Three recommendations follow.</a:t>
+            </a:r>
+          </a:p>
+        </p:txBody>
+      </p:sp>
+      <p:sp>
+        <p:nvSpPr>
+          <p:cNvPr id="4" name="Slide Number Placeholder 3"/>
+          <p:cNvSpPr>
+            <a:spLocks noGrp="1"/>
+          </p:cNvSpPr>
+          <p:nvPr>
+            <p:ph type="sldNum" idx="5" sz="quarter"/>
+          </p:nvPr>
+        </p:nvSpPr>
+        <p:spPr/>
+      </p:sp>
+    </p:spTree>
+  </p:cSld>
+  <p:clrMapOvr>
+    <a:masterClrMapping/>
+  </p:clrMapOvr>
+</p:notes>
+</file>
+
+<file path=ppt/notesSlides/notesSlide25.xml><?xml version="1.0" encoding="utf-8"?>
+<p:notes xmlns:a="http://schemas.openxmlformats.org/drawingml/2006/main" xmlns:p="http://schemas.openxmlformats.org/presentationml/2006/main" xmlns:r="http://schemas.openxmlformats.org/officeDocument/2006/relationships">
+  <p:cSld>
+    <p:spTree>
+      <p:nvGrpSpPr>
+        <p:cNvPr id="1" name=""/>
+        <p:cNvGrpSpPr/>
+        <p:nvPr/>
+      </p:nvGrpSpPr>
+      <p:grpSpPr>
+        <a:xfrm>
+          <a:off x="0" y="0"/>
+          <a:ext cx="0" cy="0"/>
+          <a:chOff x="0" y="0"/>
+          <a:chExt cx="0" cy="0"/>
+        </a:xfrm>
+      </p:grpSpPr>
+      <p:sp>
+        <p:nvSpPr>
+          <p:cNvPr id="2" name="Slide Image Placeholder 1"/>
+          <p:cNvSpPr>
+            <a:spLocks noGrp="1"/>
+          </p:cNvSpPr>
+          <p:nvPr>
+            <p:ph type="sldImg" idx="2"/>
+          </p:nvPr>
+        </p:nvSpPr>
+        <p:spPr/>
+      </p:sp>
+      <p:sp>
+        <p:nvSpPr>
+          <p:cNvPr id="3" name="Notes Placeholder 2"/>
+          <p:cNvSpPr>
+            <a:spLocks noGrp="1"/>
+          </p:cNvSpPr>
+          <p:nvPr>
+            <p:ph type="body" idx="3" sz="quarter"/>
+          </p:nvPr>
+        </p:nvSpPr>
+        <p:spPr/>
+        <p:txBody>
+          <a:bodyPr/>
+          <a:lstStyle/>
+          <a:p>
+            <a:r>
+              <a:t>Limitations. ERA5's 25 km grid smooths extremes, so station data would raise every count, but the dry-versus-humid separation is structural. Our one-cell rule flatters IMD. Physiological limits come from young, healthy adults. Next steps: station data, mortality or hospital data to validate thresholds, and a district-level operational forecast.</a:t>
+            </a:r>
+          </a:p>
+        </p:txBody>
+      </p:sp>
+      <p:sp>
+        <p:nvSpPr>
+          <p:cNvPr id="4" name="Slide Number Placeholder 3"/>
+          <p:cNvSpPr>
+            <a:spLocks noGrp="1"/>
+          </p:cNvSpPr>
+          <p:nvPr>
+            <p:ph type="sldNum" idx="5" sz="quarter"/>
+          </p:nvPr>
+        </p:nvSpPr>
+        <p:spPr/>
+      </p:sp>
+    </p:spTree>
+  </p:cSld>
+  <p:clrMapOvr>
+    <a:masterClrMapping/>
+  </p:clrMapOvr>
+</p:notes>
+</file>
+
+<file path=ppt/notesSlides/notesSlide26.xml><?xml version="1.0" encoding="utf-8"?>
+<p:notes xmlns:a="http://schemas.openxmlformats.org/drawingml/2006/main" xmlns:p="http://schemas.openxmlformats.org/presentationml/2006/main" xmlns:r="http://schemas.openxmlformats.org/officeDocument/2006/relationships">
+  <p:cSld>
+    <p:spTree>
+      <p:nvGrpSpPr>
+        <p:cNvPr id="1" name=""/>
+        <p:cNvGrpSpPr/>
+        <p:nvPr/>
+      </p:nvGrpSpPr>
+      <p:grpSpPr>
+        <a:xfrm>
+          <a:off x="0" y="0"/>
+          <a:ext cx="0" cy="0"/>
+          <a:chOff x="0" y="0"/>
+          <a:chExt cx="0" cy="0"/>
+        </a:xfrm>
+      </p:grpSpPr>
+      <p:sp>
+        <p:nvSpPr>
+          <p:cNvPr id="2" name="Slide Image Placeholder 1"/>
+          <p:cNvSpPr>
+            <a:spLocks noGrp="1"/>
+          </p:cNvSpPr>
+          <p:nvPr>
+            <p:ph type="sldImg" idx="2"/>
+          </p:nvPr>
+        </p:nvSpPr>
+        <p:spPr/>
+      </p:sp>
+      <p:sp>
+        <p:nvSpPr>
+          <p:cNvPr id="3" name="Notes Placeholder 2"/>
+          <p:cNvSpPr>
+            <a:spLocks noGrp="1"/>
+          </p:cNvSpPr>
+          <p:nvPr>
+            <p:ph type="body" idx="3" sz="quarter"/>
+          </p:nvPr>
+        </p:nvSpPr>
+        <p:spPr/>
+        <p:txBody>
+          <a:bodyPr/>
+          <a:lstStyle/>
+          <a:p>
+            <a:r>
+              <a:t>Key references.</a:t>
+            </a:r>
+          </a:p>
+        </p:txBody>
+      </p:sp>
+      <p:sp>
+        <p:nvSpPr>
+          <p:cNvPr id="4" name="Slide Number Placeholder 3"/>
+          <p:cNvSpPr>
+            <a:spLocks noGrp="1"/>
+          </p:cNvSpPr>
+          <p:nvPr>
+            <p:ph type="sldNum" idx="5" sz="quarter"/>
+          </p:nvPr>
+        </p:nvSpPr>
+        <p:spPr/>
+      </p:sp>
+    </p:spTree>
+  </p:cSld>
+  <p:clrMapOvr>
+    <a:masterClrMapping/>
+  </p:clrMapOvr>
+</p:notes>
+</file>
+
+<file path=ppt/notesSlides/notesSlide27.xml><?xml version="1.0" encoding="utf-8"?>
+<p:notes xmlns:a="http://schemas.openxmlformats.org/drawingml/2006/main" xmlns:p="http://schemas.openxmlformats.org/presentationml/2006/main" xmlns:r="http://schemas.openxmlformats.org/officeDocument/2006/relationships">
+  <p:cSld>
+    <p:spTree>
+      <p:nvGrpSpPr>
+        <p:cNvPr id="1" name=""/>
+        <p:cNvGrpSpPr/>
+        <p:nvPr/>
+      </p:nvGrpSpPr>
+      <p:grpSpPr>
+        <a:xfrm>
+          <a:off x="0" y="0"/>
+          <a:ext cx="0" cy="0"/>
+          <a:chOff x="0" y="0"/>
+          <a:chExt cx="0" cy="0"/>
+        </a:xfrm>
+      </p:grpSpPr>
+      <p:sp>
+        <p:nvSpPr>
+          <p:cNvPr id="2" name="Slide Image Placeholder 1"/>
+          <p:cNvSpPr>
+            <a:spLocks noGrp="1"/>
+          </p:cNvSpPr>
+          <p:nvPr>
+            <p:ph type="sldImg" idx="2"/>
+          </p:nvPr>
+        </p:nvSpPr>
+        <p:spPr/>
+      </p:sp>
+      <p:sp>
+        <p:nvSpPr>
+          <p:cNvPr id="3" name="Notes Placeholder 2"/>
+          <p:cNvSpPr>
+            <a:spLocks noGrp="1"/>
+          </p:cNvSpPr>
+          <p:nvPr>
+            <p:ph type="body" idx="3" sz="quarter"/>
+          </p:nvPr>
+        </p:nvSpPr>
+        <p:spPr/>
+        <p:txBody>
+          <a:bodyPr/>
+          <a:lstStyle/>
+          <a:p>
+            <a:r>
               <a:t>Thank you. Questions welcome; the dashboard can be shown live.</a:t>
             </a:r>
           </a:p>
@@ -1855,7 +2068,7 @@
           <a:lstStyle/>
           <a:p>
             <a:r>
-              <a:t>Five research questions drive the project. Each maps onto a block of the probability and statistics syllabus: interval estimation and hypothesis testing; trend tests and regression; distribution fitting and extreme-value theory; Markov chains and Monte Carlo; and logistic regression with probabilistic verification.</a:t>
+              <a:t>Six research questions drive the project. Each maps onto a block of the probability and statistics syllabus: interval estimation and hypothesis testing; trend tests and regression; distribution fitting and extreme-value theory; Markov chains and Monte Carlo; and logistic regression with probabilistic verification.</a:t>
             </a:r>
           </a:p>
         </p:txBody>
@@ -9168,7 +9381,7 @@
       <p:grpSpPr/>
       <p:pic>
         <p:nvPicPr>
-          <p:cNvPr id="2" name="Picture 1" descr="bg_content_e_dim.jpg"/>
+          <p:cNvPr id="2" name="Picture 1" descr="bg_content_c_dim.jpg"/>
           <p:cNvPicPr>
             <a:picLocks noChangeAspect="1"/>
           </p:cNvPicPr>
@@ -9227,7 +9440,7 @@
                 </a:solidFill>
                 <a:latin typeface="Poppins Light"/>
               </a:rPr>
-              <a:t>SHINY DASHBOARD: THE GAP IN ONE SCREEN</a:t>
+              <a:t>RQ6 · BASELINE ML, AND WHAT IS NEW</a:t>
             </a:r>
           </a:p>
         </p:txBody>
@@ -9275,45 +9488,16 @@
           </a:p>
         </p:txBody>
       </p:sp>
-      <p:pic>
-        <p:nvPicPr>
-          <p:cNvPr id="5" name="Picture 4" descr="dashboard_risk_crop.png"/>
-          <p:cNvPicPr>
-            <a:picLocks noChangeAspect="1"/>
-          </p:cNvPicPr>
-          <p:nvPr/>
-        </p:nvPicPr>
-        <p:blipFill>
-          <a:blip r:embed="rId4"/>
-          <a:stretch>
-            <a:fillRect/>
-          </a:stretch>
-        </p:blipFill>
-        <p:spPr>
-          <a:xfrm>
-            <a:off x="777240" y="1554480"/>
-            <a:ext cx="10607040" cy="3778758"/>
-          </a:xfrm>
-          <a:prstGeom prst="rect">
-            <a:avLst/>
-          </a:prstGeom>
-          <a:ln w="12700">
-            <a:solidFill>
-              <a:srgbClr val="444444"/>
-            </a:solidFill>
-          </a:ln>
-        </p:spPr>
-      </p:pic>
-      <p:sp>
-        <p:nvSpPr>
-          <p:cNvPr id="6" name="TextBox 5"/>
+      <p:sp>
+        <p:nvSpPr>
+          <p:cNvPr id="5" name="TextBox 4"/>
           <p:cNvSpPr txBox="1"/>
           <p:nvPr/>
         </p:nvSpPr>
         <p:spPr>
           <a:xfrm>
-            <a:off x="777240" y="5504688"/>
-            <a:ext cx="10607040" cy="365760"/>
+            <a:off x="777240" y="1691640"/>
+            <a:ext cx="5120640" cy="4572000"/>
           </a:xfrm>
           <a:prstGeom prst="rect">
             <a:avLst/>
@@ -9331,31 +9515,107 @@
                 <a:spcPct val="112000"/>
               </a:lnSpc>
               <a:spcAft>
-                <a:spcPts val="0"/>
-              </a:spcAft>
-            </a:pPr>
-            <a:r>
-              <a:rPr sz="1400" b="0" i="0">
+                <a:spcPts val="1000"/>
+              </a:spcAft>
+            </a:pPr>
+            <a:r>
+              <a:rPr sz="1450" b="0" i="0">
+                <a:solidFill>
+                  <a:srgbClr val="E08A3C"/>
+                </a:solidFill>
+                <a:latin typeface="Poppins"/>
+              </a:rPr>
+              <a:t>Set-up</a:t>
+            </a:r>
+          </a:p>
+          <a:p>
+            <a:pPr algn="l">
+              <a:lnSpc>
+                <a:spcPct val="112000"/>
+              </a:lnSpc>
+              <a:spcAft>
+                <a:spcPts val="1000"/>
+              </a:spcAft>
+            </a:pPr>
+            <a:r>
+              <a:rPr sz="1450" b="0" i="0">
                 <a:solidFill>
                   <a:srgbClr val="F2F2F2"/>
                 </a:solidFill>
                 <a:latin typeface="Poppins Light"/>
               </a:rPr>
-              <a:t>Risk calculator, Kolkata on 20 May: the IMD rule says NO ALERT, the wet-bulb (30.7 °C) says DANGER, and the model gives 99% for tomorrow.</a:t>
-            </a:r>
-          </a:p>
-        </p:txBody>
-      </p:sp>
-      <p:sp>
-        <p:nvSpPr>
-          <p:cNvPr id="7" name="TextBox 6"/>
+              <a:t>Target: will the day +1, +2 or +3 ahead be a danger day (wet-bulb ≥ 29 °C)?</a:t>
+            </a:r>
+          </a:p>
+          <a:p>
+            <a:pPr algn="l">
+              <a:lnSpc>
+                <a:spcPct val="112000"/>
+              </a:lnSpc>
+              <a:spcAft>
+                <a:spcPts val="1000"/>
+              </a:spcAft>
+            </a:pPr>
+            <a:r>
+              <a:rPr sz="1450" b="0" i="0">
+                <a:solidFill>
+                  <a:srgbClr val="F2F2F2"/>
+                </a:solidFill>
+                <a:latin typeface="Poppins Light"/>
+              </a:rPr>
+              <a:t>Baselines: climatology, IMD rule, logistic regression, decision tree (rpart), random forest (ranger, 400 trees)</a:t>
+            </a:r>
+          </a:p>
+          <a:p>
+            <a:pPr algn="l">
+              <a:lnSpc>
+                <a:spcPct val="112000"/>
+              </a:lnSpc>
+              <a:spcAft>
+                <a:spcPts val="1000"/>
+              </a:spcAft>
+            </a:pPr>
+            <a:r>
+              <a:rPr sz="1450" b="0" i="0">
+                <a:solidFill>
+                  <a:srgbClr val="F2F2F2"/>
+                </a:solidFill>
+                <a:latin typeface="Poppins Light"/>
+              </a:rPr>
+              <a:t>24 features: today's weather, 3–7-day wet-bulb history, season, city</a:t>
+            </a:r>
+          </a:p>
+          <a:p>
+            <a:pPr algn="l">
+              <a:lnSpc>
+                <a:spcPct val="112000"/>
+              </a:lnSpc>
+              <a:spcAft>
+                <a:spcPts val="1000"/>
+              </a:spcAft>
+            </a:pPr>
+            <a:r>
+              <a:rPr sz="1450" b="0" i="0">
+                <a:solidFill>
+                  <a:srgbClr val="F2F2F2"/>
+                </a:solidFill>
+                <a:latin typeface="Poppins Light"/>
+              </a:rPr>
+              <a:t>Train 1981–2014 · alert thresholds tuned on 2010–14 · test 2015–25, never seen</a:t>
+            </a:r>
+          </a:p>
+        </p:txBody>
+      </p:sp>
+      <p:sp>
+        <p:nvSpPr>
+          <p:cNvPr id="6" name="TextBox 5"/>
           <p:cNvSpPr txBox="1"/>
           <p:nvPr/>
         </p:nvSpPr>
         <p:spPr>
           <a:xfrm>
-            <a:off x="777240" y="6199632"/>
-            <a:ext cx="10607040" cy="365760"/>
+            <a:off x="6263640" y="1691640"/>
+            <a:ext cx="5120640" cy="457200"/>
           </a:xfrm>
           <a:prstGeom prst="rect">
             <a:avLst/>
@@ -9377,13 +9637,238 @@
               </a:spcAft>
             </a:pPr>
             <a:r>
-              <a:rPr sz="1300" b="0" i="0">
+              <a:rPr sz="1450" b="0" i="0">
+                <a:solidFill>
+                  <a:srgbClr val="E08A3C"/>
+                </a:solidFill>
+                <a:latin typeface="Poppins"/>
+              </a:rPr>
+              <a:t>What is new</a:t>
+            </a:r>
+          </a:p>
+        </p:txBody>
+      </p:sp>
+      <p:sp>
+        <p:nvSpPr>
+          <p:cNvPr id="7" name="Rectangle 6"/>
+          <p:cNvSpPr/>
+          <p:nvPr/>
+        </p:nvSpPr>
+        <p:spPr>
+          <a:xfrm>
+            <a:off x="6263640" y="2240280"/>
+            <a:ext cx="5120640" cy="1097280"/>
+          </a:xfrm>
+          <a:prstGeom prst="rect">
+            <a:avLst/>
+          </a:prstGeom>
+          <a:solidFill>
+            <a:srgbClr val="262626"/>
+          </a:solidFill>
+          <a:ln w="15875">
+            <a:solidFill>
+              <a:srgbClr val="F2F2F2"/>
+            </a:solidFill>
+          </a:ln>
+          <a:effectLst/>
+        </p:spPr>
+        <p:style>
+          <a:lnRef idx="1">
+            <a:schemeClr val="accent1"/>
+          </a:lnRef>
+          <a:fillRef idx="3">
+            <a:schemeClr val="accent1"/>
+          </a:fillRef>
+          <a:effectRef idx="2">
+            <a:schemeClr val="accent1"/>
+          </a:effectRef>
+          <a:fontRef idx="minor">
+            <a:schemeClr val="lt1"/>
+          </a:fontRef>
+        </p:style>
+        <p:txBody>
+          <a:bodyPr rtlCol="0" anchor="ctr" wrap="square" lIns="109728" rIns="109728" tIns="54864" bIns="54864"/>
+          <a:lstStyle/>
+          <a:p>
+            <a:pPr algn="ctr">
+              <a:lnSpc>
+                <a:spcPct val="100000"/>
+              </a:lnSpc>
+            </a:pPr>
+            <a:r>
+              <a:rPr sz="1700">
+                <a:solidFill>
+                  <a:srgbClr val="E08A3C"/>
+                </a:solidFill>
+                <a:latin typeface="Poppins"/>
+              </a:rPr>
+              <a:t>Physiology-informed features</a:t>
+            </a:r>
+          </a:p>
+          <a:p>
+            <a:pPr algn="ctr">
+              <a:lnSpc>
+                <a:spcPct val="100000"/>
+              </a:lnSpc>
+            </a:pPr>
+            <a:r>
+              <a:rPr sz="1300">
                 <a:solidFill>
                   <a:srgbClr val="A8A8A8"/>
                 </a:solidFill>
                 <a:latin typeface="Poppins Light"/>
               </a:rPr>
-              <a:t>Rscript -e 'shiny::runApp("app")'  ·  5 tabs: blind spot, trends, extremes, risk calculator, about</a:t>
+              <a:t>headroom to the 29 °C limit · closing speed · days-to-limit</a:t>
+            </a:r>
+          </a:p>
+        </p:txBody>
+      </p:sp>
+      <p:sp>
+        <p:nvSpPr>
+          <p:cNvPr id="8" name="Rectangle 7"/>
+          <p:cNvSpPr/>
+          <p:nvPr/>
+        </p:nvSpPr>
+        <p:spPr>
+          <a:xfrm>
+            <a:off x="6263640" y="3520440"/>
+            <a:ext cx="5120640" cy="1097280"/>
+          </a:xfrm>
+          <a:prstGeom prst="rect">
+            <a:avLst/>
+          </a:prstGeom>
+          <a:solidFill>
+            <a:srgbClr val="262626"/>
+          </a:solidFill>
+          <a:ln w="15875">
+            <a:solidFill>
+              <a:srgbClr val="F2F2F2"/>
+            </a:solidFill>
+          </a:ln>
+          <a:effectLst/>
+        </p:spPr>
+        <p:style>
+          <a:lnRef idx="1">
+            <a:schemeClr val="accent1"/>
+          </a:lnRef>
+          <a:fillRef idx="3">
+            <a:schemeClr val="accent1"/>
+          </a:fillRef>
+          <a:effectRef idx="2">
+            <a:schemeClr val="accent1"/>
+          </a:effectRef>
+          <a:fontRef idx="minor">
+            <a:schemeClr val="lt1"/>
+          </a:fontRef>
+        </p:style>
+        <p:txBody>
+          <a:bodyPr rtlCol="0" anchor="ctr" wrap="square" lIns="109728" rIns="109728" tIns="54864" bIns="54864"/>
+          <a:lstStyle/>
+          <a:p>
+            <a:pPr algn="ctr">
+              <a:lnSpc>
+                <a:spcPct val="100000"/>
+              </a:lnSpc>
+            </a:pPr>
+            <a:r>
+              <a:rPr sz="1700">
+                <a:solidFill>
+                  <a:srgbClr val="E08A3C"/>
+                </a:solidFill>
+                <a:latin typeface="Poppins"/>
+              </a:rPr>
+              <a:t>Hybrid alert, not a replacement</a:t>
+            </a:r>
+          </a:p>
+          <a:p>
+            <a:pPr algn="ctr">
+              <a:lnSpc>
+                <a:spcPct val="100000"/>
+              </a:lnSpc>
+            </a:pPr>
+            <a:r>
+              <a:rPr sz="1300">
+                <a:solidFill>
+                  <a:srgbClr val="A8A8A8"/>
+                </a:solidFill>
+                <a:latin typeface="Poppins Light"/>
+              </a:rPr>
+              <a:t>IMD rule OR ML layer, scored on blind-spot recovery</a:t>
+            </a:r>
+          </a:p>
+        </p:txBody>
+      </p:sp>
+      <p:sp>
+        <p:nvSpPr>
+          <p:cNvPr id="9" name="Rectangle 8"/>
+          <p:cNvSpPr/>
+          <p:nvPr/>
+        </p:nvSpPr>
+        <p:spPr>
+          <a:xfrm>
+            <a:off x="6263640" y="4800600"/>
+            <a:ext cx="5120640" cy="1097280"/>
+          </a:xfrm>
+          <a:prstGeom prst="rect">
+            <a:avLst/>
+          </a:prstGeom>
+          <a:solidFill>
+            <a:srgbClr val="262626"/>
+          </a:solidFill>
+          <a:ln w="15875">
+            <a:solidFill>
+              <a:srgbClr val="F2F2F2"/>
+            </a:solidFill>
+          </a:ln>
+          <a:effectLst/>
+        </p:spPr>
+        <p:style>
+          <a:lnRef idx="1">
+            <a:schemeClr val="accent1"/>
+          </a:lnRef>
+          <a:fillRef idx="3">
+            <a:schemeClr val="accent1"/>
+          </a:fillRef>
+          <a:effectRef idx="2">
+            <a:schemeClr val="accent1"/>
+          </a:effectRef>
+          <a:fontRef idx="minor">
+            <a:schemeClr val="lt1"/>
+          </a:fontRef>
+        </p:style>
+        <p:txBody>
+          <a:bodyPr rtlCol="0" anchor="ctr" wrap="square" lIns="109728" rIns="109728" tIns="54864" bIns="54864"/>
+          <a:lstStyle/>
+          <a:p>
+            <a:pPr algn="ctr">
+              <a:lnSpc>
+                <a:spcPct val="100000"/>
+              </a:lnSpc>
+            </a:pPr>
+            <a:r>
+              <a:rPr sz="1700">
+                <a:solidFill>
+                  <a:srgbClr val="E08A3C"/>
+                </a:solidFill>
+                <a:latin typeface="Poppins"/>
+              </a:rPr>
+              <a:t>Zero-history cities</a:t>
+            </a:r>
+          </a:p>
+          <a:p>
+            <a:pPr algn="ctr">
+              <a:lnSpc>
+                <a:spcPct val="100000"/>
+              </a:lnSpc>
+            </a:pPr>
+            <a:r>
+              <a:rPr sz="1300">
+                <a:solidFill>
+                  <a:srgbClr val="A8A8A8"/>
+                </a:solidFill>
+                <a:latin typeface="Poppins Light"/>
+              </a:rPr>
+              <a:t>leave-one-city-out: warn where no labelled past exists</a:t>
             </a:r>
           </a:p>
         </p:txBody>
@@ -9408,7 +9893,7 @@
       <p:grpSpPr/>
       <p:pic>
         <p:nvPicPr>
-          <p:cNvPr id="2" name="Picture 1" descr="bg_content_c.jpg"/>
+          <p:cNvPr id="2" name="Picture 1" descr="bg_content_a_dim.jpg"/>
           <p:cNvPicPr>
             <a:picLocks noChangeAspect="1"/>
           </p:cNvPicPr>
@@ -9467,7 +9952,7 @@
                 </a:solidFill>
                 <a:latin typeface="Poppins Light"/>
               </a:rPr>
-              <a:t>CONCLUSIONS &amp; RECOMMENDATIONS</a:t>
+              <a:t>RQ6 · RANDOM FOREST LEADS AT EVERY LEAD TIME</a:t>
             </a:r>
           </a:p>
         </p:txBody>
@@ -9515,16 +10000,82 @@
           </a:p>
         </p:txBody>
       </p:sp>
-      <p:sp>
-        <p:nvSpPr>
-          <p:cNvPr id="5" name="TextBox 4"/>
+      <p:pic>
+        <p:nvPicPr>
+          <p:cNvPr id="5" name="Picture 4" descr="fig_ml_models.png"/>
+          <p:cNvPicPr>
+            <a:picLocks noChangeAspect="1"/>
+          </p:cNvPicPr>
+          <p:nvPr/>
+        </p:nvPicPr>
+        <p:blipFill>
+          <a:blip r:embed="rId4"/>
+          <a:stretch>
+            <a:fillRect/>
+          </a:stretch>
+        </p:blipFill>
+        <p:spPr>
+          <a:xfrm>
+            <a:off x="515721" y="1463040"/>
+            <a:ext cx="7563916" cy="4023360"/>
+          </a:xfrm>
+          <a:prstGeom prst="rect">
+            <a:avLst/>
+          </a:prstGeom>
+        </p:spPr>
+      </p:pic>
+      <p:sp>
+        <p:nvSpPr>
+          <p:cNvPr id="6" name="TextBox 5"/>
           <p:cNvSpPr txBox="1"/>
           <p:nvPr/>
         </p:nvSpPr>
         <p:spPr>
           <a:xfrm>
-            <a:off x="777240" y="1645920"/>
-            <a:ext cx="822960" cy="411480"/>
+            <a:off x="8412480" y="1554480"/>
+            <a:ext cx="3474720" cy="685800"/>
+          </a:xfrm>
+          <a:prstGeom prst="rect">
+            <a:avLst/>
+          </a:prstGeom>
+          <a:noFill/>
+        </p:spPr>
+        <p:txBody>
+          <a:bodyPr wrap="square" lIns="0" rIns="0" tIns="0" bIns="0" anchor="b">
+            <a:spAutoFit/>
+          </a:bodyPr>
+          <a:lstStyle/>
+          <a:p>
+            <a:pPr algn="l">
+              <a:lnSpc>
+                <a:spcPct val="112000"/>
+              </a:lnSpc>
+              <a:spcAft>
+                <a:spcPts val="0"/>
+              </a:spcAft>
+            </a:pPr>
+            <a:r>
+              <a:rPr sz="2800" b="0" i="0">
+                <a:solidFill>
+                  <a:srgbClr val="E08A3C"/>
+                </a:solidFill>
+                <a:latin typeface="Poppins Light"/>
+              </a:rPr>
+              <a:t>AUC 0.95</a:t>
+            </a:r>
+          </a:p>
+        </p:txBody>
+      </p:sp>
+      <p:sp>
+        <p:nvSpPr>
+          <p:cNvPr id="7" name="TextBox 6"/>
+          <p:cNvSpPr txBox="1"/>
+          <p:nvPr/>
+        </p:nvSpPr>
+        <p:spPr>
+          <a:xfrm>
+            <a:off x="8412480" y="2304288"/>
+            <a:ext cx="3474720" cy="822960"/>
           </a:xfrm>
           <a:prstGeom prst="rect">
             <a:avLst/>
@@ -9539,6 +10090,48 @@
           <a:p>
             <a:pPr algn="l">
               <a:lnSpc>
+                <a:spcPct val="105000"/>
+              </a:lnSpc>
+              <a:spcAft>
+                <a:spcPts val="0"/>
+              </a:spcAft>
+            </a:pPr>
+            <a:r>
+              <a:rPr sz="1300" b="0" i="0">
+                <a:solidFill>
+                  <a:srgbClr val="A8A8A8"/>
+                </a:solidFill>
+                <a:latin typeface="Poppins Light"/>
+              </a:rPr>
+              <a:t>random forest, +1 day (logistic 0.92, IMD rule 0.61)</a:t>
+            </a:r>
+          </a:p>
+        </p:txBody>
+      </p:sp>
+      <p:sp>
+        <p:nvSpPr>
+          <p:cNvPr id="8" name="TextBox 7"/>
+          <p:cNvSpPr txBox="1"/>
+          <p:nvPr/>
+        </p:nvSpPr>
+        <p:spPr>
+          <a:xfrm>
+            <a:off x="8412480" y="3063240"/>
+            <a:ext cx="3474720" cy="685800"/>
+          </a:xfrm>
+          <a:prstGeom prst="rect">
+            <a:avLst/>
+          </a:prstGeom>
+          <a:noFill/>
+        </p:spPr>
+        <p:txBody>
+          <a:bodyPr wrap="square" lIns="0" rIns="0" tIns="0" bIns="0" anchor="b">
+            <a:spAutoFit/>
+          </a:bodyPr>
+          <a:lstStyle/>
+          <a:p>
+            <a:pPr algn="l">
+              <a:lnSpc>
                 <a:spcPct val="112000"/>
               </a:lnSpc>
               <a:spcAft>
@@ -9546,27 +10139,27 @@
               </a:spcAft>
             </a:pPr>
             <a:r>
-              <a:rPr sz="1500" b="0" i="0">
+              <a:rPr sz="2800" b="0" i="0">
                 <a:solidFill>
                   <a:srgbClr val="E08A3C"/>
                 </a:solidFill>
-                <a:latin typeface="Poppins"/>
-              </a:rPr>
-              <a:t>RQ1</a:t>
-            </a:r>
-          </a:p>
-        </p:txBody>
-      </p:sp>
-      <p:sp>
-        <p:nvSpPr>
-          <p:cNvPr id="6" name="TextBox 5"/>
+                <a:latin typeface="Poppins Light"/>
+              </a:rPr>
+              <a:t>AUC 0.89</a:t>
+            </a:r>
+          </a:p>
+        </p:txBody>
+      </p:sp>
+      <p:sp>
+        <p:nvSpPr>
+          <p:cNvPr id="9" name="TextBox 8"/>
           <p:cNvSpPr txBox="1"/>
           <p:nvPr/>
         </p:nvSpPr>
         <p:spPr>
           <a:xfrm>
-            <a:off x="1600200" y="1645920"/>
-            <a:ext cx="9692640" cy="411480"/>
+            <a:off x="8412480" y="3813048"/>
+            <a:ext cx="3474720" cy="822960"/>
           </a:xfrm>
           <a:prstGeom prst="rect">
             <a:avLst/>
@@ -9581,6 +10174,48 @@
           <a:p>
             <a:pPr algn="l">
               <a:lnSpc>
+                <a:spcPct val="105000"/>
+              </a:lnSpc>
+              <a:spcAft>
+                <a:spcPts val="0"/>
+              </a:spcAft>
+            </a:pPr>
+            <a:r>
+              <a:rPr sz="1300" b="0" i="0">
+                <a:solidFill>
+                  <a:srgbClr val="A8A8A8"/>
+                </a:solidFill>
+                <a:latin typeface="Poppins Light"/>
+              </a:rPr>
+              <a:t>still at +3 days, vs 0.82 for climatology</a:t>
+            </a:r>
+          </a:p>
+        </p:txBody>
+      </p:sp>
+      <p:sp>
+        <p:nvSpPr>
+          <p:cNvPr id="10" name="TextBox 9"/>
+          <p:cNvSpPr txBox="1"/>
+          <p:nvPr/>
+        </p:nvSpPr>
+        <p:spPr>
+          <a:xfrm>
+            <a:off x="8412480" y="4572000"/>
+            <a:ext cx="3474720" cy="685800"/>
+          </a:xfrm>
+          <a:prstGeom prst="rect">
+            <a:avLst/>
+          </a:prstGeom>
+          <a:noFill/>
+        </p:spPr>
+        <p:txBody>
+          <a:bodyPr wrap="square" lIns="0" rIns="0" tIns="0" bIns="0" anchor="b">
+            <a:spAutoFit/>
+          </a:bodyPr>
+          <a:lstStyle/>
+          <a:p>
+            <a:pPr algn="l">
+              <a:lnSpc>
                 <a:spcPct val="112000"/>
               </a:lnSpc>
               <a:spcAft>
@@ -9588,27 +10223,27 @@
               </a:spcAft>
             </a:pPr>
             <a:r>
-              <a:rPr sz="1500" b="0" i="0">
-                <a:solidFill>
-                  <a:srgbClr val="F2F2F2"/>
-                </a:solidFill>
-                <a:latin typeface="Poppins Light"/>
-              </a:rPr>
-              <a:t>The IMD rule misses 96% of dangerous humid-heat days, in every city</a:t>
-            </a:r>
-          </a:p>
-        </p:txBody>
-      </p:sp>
-      <p:sp>
-        <p:nvSpPr>
-          <p:cNvPr id="7" name="TextBox 6"/>
+              <a:rPr sz="2800" b="0" i="0">
+                <a:solidFill>
+                  <a:srgbClr val="E08A3C"/>
+                </a:solidFill>
+                <a:latin typeface="Poppins Light"/>
+              </a:rPr>
+              <a:t>+22%</a:t>
+            </a:r>
+          </a:p>
+        </p:txBody>
+      </p:sp>
+      <p:sp>
+        <p:nvSpPr>
+          <p:cNvPr id="11" name="TextBox 10"/>
           <p:cNvSpPr txBox="1"/>
           <p:nvPr/>
         </p:nvSpPr>
         <p:spPr>
           <a:xfrm>
-            <a:off x="777240" y="2121408"/>
-            <a:ext cx="822960" cy="411480"/>
+            <a:off x="8412480" y="5321808"/>
+            <a:ext cx="3474720" cy="822960"/>
           </a:xfrm>
           <a:prstGeom prst="rect">
             <a:avLst/>
@@ -9623,34 +10258,34 @@
           <a:p>
             <a:pPr algn="l">
               <a:lnSpc>
-                <a:spcPct val="112000"/>
+                <a:spcPct val="105000"/>
               </a:lnSpc>
               <a:spcAft>
                 <a:spcPts val="0"/>
               </a:spcAft>
             </a:pPr>
             <a:r>
-              <a:rPr sz="1500" b="0" i="0">
-                <a:solidFill>
-                  <a:srgbClr val="E08A3C"/>
-                </a:solidFill>
-                <a:latin typeface="Poppins"/>
-              </a:rPr>
-              <a:t>RQ2</a:t>
-            </a:r>
-          </a:p>
-        </p:txBody>
-      </p:sp>
-      <p:sp>
-        <p:nvSpPr>
-          <p:cNvPr id="8" name="TextBox 7"/>
+              <a:rPr sz="1300" b="0" i="0">
+                <a:solidFill>
+                  <a:srgbClr val="A8A8A8"/>
+                </a:solidFill>
+                <a:latin typeface="Poppins Light"/>
+              </a:rPr>
+              <a:t>Brier skill over climatology, +1 day</a:t>
+            </a:r>
+          </a:p>
+        </p:txBody>
+      </p:sp>
+      <p:sp>
+        <p:nvSpPr>
+          <p:cNvPr id="12" name="TextBox 11"/>
           <p:cNvSpPr txBox="1"/>
           <p:nvPr/>
         </p:nvSpPr>
         <p:spPr>
           <a:xfrm>
-            <a:off x="1600200" y="2121408"/>
-            <a:ext cx="9692640" cy="411480"/>
+            <a:off x="777240" y="5760720"/>
+            <a:ext cx="7315200" cy="731520"/>
           </a:xfrm>
           <a:prstGeom prst="rect">
             <a:avLst/>
@@ -9672,499 +10307,13 @@
               </a:spcAft>
             </a:pPr>
             <a:r>
-              <a:rPr sz="1500" b="0" i="0">
-                <a:solidFill>
-                  <a:srgbClr val="F2F2F2"/>
-                </a:solidFill>
-                <a:latin typeface="Poppins Light"/>
-              </a:rPr>
-              <a:t>Danger days grow ×1.54 per decade; Apr–Jun wet-bulb is up 0.53 °C</a:t>
-            </a:r>
-          </a:p>
-        </p:txBody>
-      </p:sp>
-      <p:sp>
-        <p:nvSpPr>
-          <p:cNvPr id="9" name="TextBox 8"/>
-          <p:cNvSpPr txBox="1"/>
-          <p:nvPr/>
-        </p:nvSpPr>
-        <p:spPr>
-          <a:xfrm>
-            <a:off x="777240" y="2596896"/>
-            <a:ext cx="822960" cy="411480"/>
-          </a:xfrm>
-          <a:prstGeom prst="rect">
-            <a:avLst/>
-          </a:prstGeom>
-          <a:noFill/>
-        </p:spPr>
-        <p:txBody>
-          <a:bodyPr wrap="square" lIns="0" rIns="0" tIns="0" bIns="0" anchor="t">
-            <a:spAutoFit/>
-          </a:bodyPr>
-          <a:lstStyle/>
-          <a:p>
-            <a:pPr algn="l">
-              <a:lnSpc>
-                <a:spcPct val="112000"/>
-              </a:lnSpc>
-              <a:spcAft>
-                <a:spcPts val="0"/>
-              </a:spcAft>
-            </a:pPr>
-            <a:r>
-              <a:rPr sz="1500" b="0" i="0">
-                <a:solidFill>
-                  <a:srgbClr val="E08A3C"/>
-                </a:solidFill>
-                <a:latin typeface="Poppins"/>
-              </a:rPr>
-              <a:t>RQ3</a:t>
-            </a:r>
-          </a:p>
-        </p:txBody>
-      </p:sp>
-      <p:sp>
-        <p:nvSpPr>
-          <p:cNvPr id="10" name="TextBox 9"/>
-          <p:cNvSpPr txBox="1"/>
-          <p:nvPr/>
-        </p:nvSpPr>
-        <p:spPr>
-          <a:xfrm>
-            <a:off x="1600200" y="2596896"/>
-            <a:ext cx="9692640" cy="411480"/>
-          </a:xfrm>
-          <a:prstGeom prst="rect">
-            <a:avLst/>
-          </a:prstGeom>
-          <a:noFill/>
-        </p:spPr>
-        <p:txBody>
-          <a:bodyPr wrap="square" lIns="0" rIns="0" tIns="0" bIns="0" anchor="t">
-            <a:spAutoFit/>
-          </a:bodyPr>
-          <a:lstStyle/>
-          <a:p>
-            <a:pPr algn="l">
-              <a:lnSpc>
-                <a:spcPct val="112000"/>
-              </a:lnSpc>
-              <a:spcAft>
-                <a:spcPts val="0"/>
-              </a:spcAft>
-            </a:pPr>
-            <a:r>
-              <a:rPr sz="1500" b="0" i="0">
-                <a:solidFill>
-                  <a:srgbClr val="F2F2F2"/>
-                </a:solidFill>
-                <a:latin typeface="Poppins Light"/>
-              </a:rPr>
-              <a:t>Tail shifting in 7/10 cities; Chennai's 1985 50-year extreme is now 1-in-2.6</a:t>
-            </a:r>
-          </a:p>
-        </p:txBody>
-      </p:sp>
-      <p:sp>
-        <p:nvSpPr>
-          <p:cNvPr id="11" name="TextBox 10"/>
-          <p:cNvSpPr txBox="1"/>
-          <p:nvPr/>
-        </p:nvSpPr>
-        <p:spPr>
-          <a:xfrm>
-            <a:off x="777240" y="3072384"/>
-            <a:ext cx="822960" cy="411480"/>
-          </a:xfrm>
-          <a:prstGeom prst="rect">
-            <a:avLst/>
-          </a:prstGeom>
-          <a:noFill/>
-        </p:spPr>
-        <p:txBody>
-          <a:bodyPr wrap="square" lIns="0" rIns="0" tIns="0" bIns="0" anchor="t">
-            <a:spAutoFit/>
-          </a:bodyPr>
-          <a:lstStyle/>
-          <a:p>
-            <a:pPr algn="l">
-              <a:lnSpc>
-                <a:spcPct val="112000"/>
-              </a:lnSpc>
-              <a:spcAft>
-                <a:spcPts val="0"/>
-              </a:spcAft>
-            </a:pPr>
-            <a:r>
-              <a:rPr sz="1500" b="0" i="0">
-                <a:solidFill>
-                  <a:srgbClr val="E08A3C"/>
-                </a:solidFill>
-                <a:latin typeface="Poppins"/>
-              </a:rPr>
-              <a:t>RQ4</a:t>
-            </a:r>
-          </a:p>
-        </p:txBody>
-      </p:sp>
-      <p:sp>
-        <p:nvSpPr>
-          <p:cNvPr id="12" name="TextBox 11"/>
-          <p:cNvSpPr txBox="1"/>
-          <p:nvPr/>
-        </p:nvSpPr>
-        <p:spPr>
-          <a:xfrm>
-            <a:off x="1600200" y="3072384"/>
-            <a:ext cx="9692640" cy="411480"/>
-          </a:xfrm>
-          <a:prstGeom prst="rect">
-            <a:avLst/>
-          </a:prstGeom>
-          <a:noFill/>
-        </p:spPr>
-        <p:txBody>
-          <a:bodyPr wrap="square" lIns="0" rIns="0" tIns="0" bIns="0" anchor="t">
-            <a:spAutoFit/>
-          </a:bodyPr>
-          <a:lstStyle/>
-          <a:p>
-            <a:pPr algn="l">
-              <a:lnSpc>
-                <a:spcPct val="112000"/>
-              </a:lnSpc>
-              <a:spcAft>
-                <a:spcPts val="0"/>
-              </a:spcAft>
-            </a:pPr>
-            <a:r>
-              <a:rPr sz="1500" b="0" i="0">
-                <a:solidFill>
-                  <a:srgbClr val="F2F2F2"/>
-                </a:solidFill>
-                <a:latin typeface="Poppins Light"/>
-              </a:rPr>
-              <a:t>Danger persists in spells; 3-day spells are now far more likely</a:t>
-            </a:r>
-          </a:p>
-        </p:txBody>
-      </p:sp>
-      <p:sp>
-        <p:nvSpPr>
-          <p:cNvPr id="13" name="TextBox 12"/>
-          <p:cNvSpPr txBox="1"/>
-          <p:nvPr/>
-        </p:nvSpPr>
-        <p:spPr>
-          <a:xfrm>
-            <a:off x="777240" y="3547872"/>
-            <a:ext cx="822960" cy="411480"/>
-          </a:xfrm>
-          <a:prstGeom prst="rect">
-            <a:avLst/>
-          </a:prstGeom>
-          <a:noFill/>
-        </p:spPr>
-        <p:txBody>
-          <a:bodyPr wrap="square" lIns="0" rIns="0" tIns="0" bIns="0" anchor="t">
-            <a:spAutoFit/>
-          </a:bodyPr>
-          <a:lstStyle/>
-          <a:p>
-            <a:pPr algn="l">
-              <a:lnSpc>
-                <a:spcPct val="112000"/>
-              </a:lnSpc>
-              <a:spcAft>
-                <a:spcPts val="0"/>
-              </a:spcAft>
-            </a:pPr>
-            <a:r>
-              <a:rPr sz="1500" b="0" i="0">
-                <a:solidFill>
-                  <a:srgbClr val="E08A3C"/>
-                </a:solidFill>
-                <a:latin typeface="Poppins"/>
-              </a:rPr>
-              <a:t>RQ5</a:t>
-            </a:r>
-          </a:p>
-        </p:txBody>
-      </p:sp>
-      <p:sp>
-        <p:nvSpPr>
-          <p:cNvPr id="14" name="TextBox 13"/>
-          <p:cNvSpPr txBox="1"/>
-          <p:nvPr/>
-        </p:nvSpPr>
-        <p:spPr>
-          <a:xfrm>
-            <a:off x="1600200" y="3547872"/>
-            <a:ext cx="9692640" cy="411480"/>
-          </a:xfrm>
-          <a:prstGeom prst="rect">
-            <a:avLst/>
-          </a:prstGeom>
-          <a:noFill/>
-        </p:spPr>
-        <p:txBody>
-          <a:bodyPr wrap="square" lIns="0" rIns="0" tIns="0" bIns="0" anchor="t">
-            <a:spAutoFit/>
-          </a:bodyPr>
-          <a:lstStyle/>
-          <a:p>
-            <a:pPr algn="l">
-              <a:lnSpc>
-                <a:spcPct val="112000"/>
-              </a:lnSpc>
-              <a:spcAft>
-                <a:spcPts val="0"/>
-              </a:spcAft>
-            </a:pPr>
-            <a:r>
-              <a:rPr sz="1500" b="0" i="0">
-                <a:solidFill>
-                  <a:srgbClr val="F2F2F2"/>
-                </a:solidFill>
-                <a:latin typeface="Poppins Light"/>
-              </a:rPr>
-              <a:t>A logistic warning reaches AUC 0.92 vs 0.61, and is calibrated</a:t>
-            </a:r>
-          </a:p>
-        </p:txBody>
-      </p:sp>
-      <p:cxnSp>
-        <p:nvCxnSpPr>
-          <p:cNvPr id="15" name="Arrow bullet"/>
-          <p:cNvCxnSpPr/>
-          <p:nvPr/>
-        </p:nvCxnSpPr>
-        <p:spPr>
-          <a:xfrm flipV="1">
-            <a:off x="777240" y="4420616"/>
-            <a:ext cx="155448" cy="155448"/>
-          </a:xfrm>
-          <a:prstGeom prst="line">
-            <a:avLst/>
-          </a:prstGeom>
-          <a:ln w="20320">
-            <a:solidFill>
-              <a:srgbClr val="E3F04F"/>
-            </a:solidFill>
-            <a:tailEnd type="triangle" w="sm" len="sm"/>
-          </a:ln>
-        </p:spPr>
-        <p:style>
-          <a:lnRef idx="2">
-            <a:schemeClr val="accent1"/>
-          </a:lnRef>
-          <a:fillRef idx="0">
-            <a:schemeClr val="accent1"/>
-          </a:fillRef>
-          <a:effectRef idx="1">
-            <a:schemeClr val="accent1"/>
-          </a:effectRef>
-          <a:fontRef idx="minor">
-            <a:schemeClr val="tx1"/>
-          </a:fontRef>
-        </p:style>
-      </p:cxnSp>
-      <p:sp>
-        <p:nvSpPr>
-          <p:cNvPr id="16" name="TextBox 15"/>
-          <p:cNvSpPr txBox="1"/>
-          <p:nvPr/>
-        </p:nvSpPr>
-        <p:spPr>
-          <a:xfrm>
-            <a:off x="1124712" y="4343400"/>
-            <a:ext cx="10442448" cy="548640"/>
-          </a:xfrm>
-          <a:prstGeom prst="rect">
-            <a:avLst/>
-          </a:prstGeom>
-          <a:noFill/>
-        </p:spPr>
-        <p:txBody>
-          <a:bodyPr wrap="square" lIns="0" rIns="0" tIns="0" bIns="0" anchor="t">
-            <a:spAutoFit/>
-          </a:bodyPr>
-          <a:lstStyle/>
-          <a:p>
-            <a:pPr algn="l">
-              <a:lnSpc>
-                <a:spcPct val="105000"/>
-              </a:lnSpc>
-              <a:spcAft>
-                <a:spcPts val="0"/>
-              </a:spcAft>
-            </a:pPr>
-            <a:r>
-              <a:rPr sz="1600" b="0" i="0">
-                <a:solidFill>
-                  <a:srgbClr val="F2F2F2"/>
-                </a:solidFill>
-                <a:latin typeface="Poppins Light"/>
-              </a:rPr>
-              <a:t>Add a humidity-aware trigger (wet-bulb or Heat Index) to heatwave declarations</a:t>
-            </a:r>
-          </a:p>
-        </p:txBody>
-      </p:sp>
-      <p:cxnSp>
-        <p:nvCxnSpPr>
-          <p:cNvPr id="17" name="Arrow bullet"/>
-          <p:cNvCxnSpPr/>
-          <p:nvPr/>
-        </p:nvCxnSpPr>
-        <p:spPr>
-          <a:xfrm flipV="1">
-            <a:off x="777240" y="4969256"/>
-            <a:ext cx="155448" cy="155447"/>
-          </a:xfrm>
-          <a:prstGeom prst="line">
-            <a:avLst/>
-          </a:prstGeom>
-          <a:ln w="20320">
-            <a:solidFill>
-              <a:srgbClr val="E3F04F"/>
-            </a:solidFill>
-            <a:tailEnd type="triangle" w="sm" len="sm"/>
-          </a:ln>
-        </p:spPr>
-        <p:style>
-          <a:lnRef idx="2">
-            <a:schemeClr val="accent1"/>
-          </a:lnRef>
-          <a:fillRef idx="0">
-            <a:schemeClr val="accent1"/>
-          </a:fillRef>
-          <a:effectRef idx="1">
-            <a:schemeClr val="accent1"/>
-          </a:effectRef>
-          <a:fontRef idx="minor">
-            <a:schemeClr val="tx1"/>
-          </a:fontRef>
-        </p:style>
-      </p:cxnSp>
-      <p:sp>
-        <p:nvSpPr>
-          <p:cNvPr id="18" name="TextBox 17"/>
-          <p:cNvSpPr txBox="1"/>
-          <p:nvPr/>
-        </p:nvSpPr>
-        <p:spPr>
-          <a:xfrm>
-            <a:off x="1124712" y="4892040"/>
-            <a:ext cx="10442448" cy="548640"/>
-          </a:xfrm>
-          <a:prstGeom prst="rect">
-            <a:avLst/>
-          </a:prstGeom>
-          <a:noFill/>
-        </p:spPr>
-        <p:txBody>
-          <a:bodyPr wrap="square" lIns="0" rIns="0" tIns="0" bIns="0" anchor="t">
-            <a:spAutoFit/>
-          </a:bodyPr>
-          <a:lstStyle/>
-          <a:p>
-            <a:pPr algn="l">
-              <a:lnSpc>
-                <a:spcPct val="105000"/>
-              </a:lnSpc>
-              <a:spcAft>
-                <a:spcPts val="0"/>
-              </a:spcAft>
-            </a:pPr>
-            <a:r>
-              <a:rPr sz="1600" b="0" i="0">
-                <a:solidFill>
-                  <a:srgbClr val="F2F2F2"/>
-                </a:solidFill>
-                <a:latin typeface="Poppins Light"/>
-              </a:rPr>
-              <a:t>Replace fixed national cut-offs with local, probabilistic thresholds and return periods</a:t>
-            </a:r>
-          </a:p>
-        </p:txBody>
-      </p:sp>
-      <p:cxnSp>
-        <p:nvCxnSpPr>
-          <p:cNvPr id="19" name="Arrow bullet"/>
-          <p:cNvCxnSpPr/>
-          <p:nvPr/>
-        </p:nvCxnSpPr>
-        <p:spPr>
-          <a:xfrm flipV="1">
-            <a:off x="777240" y="5517896"/>
-            <a:ext cx="155448" cy="155448"/>
-          </a:xfrm>
-          <a:prstGeom prst="line">
-            <a:avLst/>
-          </a:prstGeom>
-          <a:ln w="20320">
-            <a:solidFill>
-              <a:srgbClr val="E3F04F"/>
-            </a:solidFill>
-            <a:tailEnd type="triangle" w="sm" len="sm"/>
-          </a:ln>
-        </p:spPr>
-        <p:style>
-          <a:lnRef idx="2">
-            <a:schemeClr val="accent1"/>
-          </a:lnRef>
-          <a:fillRef idx="0">
-            <a:schemeClr val="accent1"/>
-          </a:fillRef>
-          <a:effectRef idx="1">
-            <a:schemeClr val="accent1"/>
-          </a:effectRef>
-          <a:fontRef idx="minor">
-            <a:schemeClr val="tx1"/>
-          </a:fontRef>
-        </p:style>
-      </p:cxnSp>
-      <p:sp>
-        <p:nvSpPr>
-          <p:cNvPr id="20" name="TextBox 19"/>
-          <p:cNvSpPr txBox="1"/>
-          <p:nvPr/>
-        </p:nvSpPr>
-        <p:spPr>
-          <a:xfrm>
-            <a:off x="1124712" y="5440680"/>
-            <a:ext cx="10442448" cy="548640"/>
-          </a:xfrm>
-          <a:prstGeom prst="rect">
-            <a:avLst/>
-          </a:prstGeom>
-          <a:noFill/>
-        </p:spPr>
-        <p:txBody>
-          <a:bodyPr wrap="square" lIns="0" rIns="0" tIns="0" bIns="0" anchor="t">
-            <a:spAutoFit/>
-          </a:bodyPr>
-          <a:lstStyle/>
-          <a:p>
-            <a:pPr algn="l">
-              <a:lnSpc>
-                <a:spcPct val="105000"/>
-              </a:lnSpc>
-              <a:spcAft>
-                <a:spcPts val="0"/>
-              </a:spcAft>
-            </a:pPr>
-            <a:r>
-              <a:rPr sz="1600" b="0" i="0">
-                <a:solidFill>
-                  <a:srgbClr val="F2F2F2"/>
-                </a:solidFill>
-                <a:latin typeface="Poppins Light"/>
-              </a:rPr>
-              <a:t>Prioritise Kolkata, Bhubaneswar, Visakhapatnam and Chennai, where silent days dominate</a:t>
+              <a:rPr sz="1400" b="0" i="0">
+                <a:solidFill>
+                  <a:srgbClr val="A8A8A8"/>
+                </a:solidFill>
+                <a:latin typeface="Poppins Light"/>
+              </a:rPr>
+              <a:t>Headroom to the physiological limit ranks #5 of 24 features. One tree is the weakest model; a forest of 400 fixes its variance.</a:t>
             </a:r>
           </a:p>
         </p:txBody>
@@ -10189,7 +10338,7 @@
       <p:grpSpPr/>
       <p:pic>
         <p:nvPicPr>
-          <p:cNvPr id="2" name="Picture 1" descr="bg_content_d.jpg"/>
+          <p:cNvPr id="2" name="Picture 1" descr="bg_content_e_dim.jpg"/>
           <p:cNvPicPr>
             <a:picLocks noChangeAspect="1"/>
           </p:cNvPicPr>
@@ -10248,7 +10397,7 @@
                 </a:solidFill>
                 <a:latin typeface="Poppins Light"/>
               </a:rPr>
-              <a:t>LIMITATIONS &amp; FUTURE WORK</a:t>
+              <a:t>NOVELTY · CLOSING THE BLIND SPOT, ANYWHERE</a:t>
             </a:r>
           </a:p>
         </p:txBody>
@@ -10296,16 +10445,82 @@
           </a:p>
         </p:txBody>
       </p:sp>
-      <p:sp>
-        <p:nvSpPr>
-          <p:cNvPr id="5" name="TextBox 4"/>
+      <p:pic>
+        <p:nvPicPr>
+          <p:cNvPr id="5" name="Picture 4" descr="fig_ml_hybrid_transfer.png"/>
+          <p:cNvPicPr>
+            <a:picLocks noChangeAspect="1"/>
+          </p:cNvPicPr>
+          <p:nvPr/>
+        </p:nvPicPr>
+        <p:blipFill>
+          <a:blip r:embed="rId4"/>
+          <a:stretch>
+            <a:fillRect/>
+          </a:stretch>
+        </p:blipFill>
+        <p:spPr>
+          <a:xfrm>
+            <a:off x="515721" y="1463040"/>
+            <a:ext cx="7563916" cy="4023360"/>
+          </a:xfrm>
+          <a:prstGeom prst="rect">
+            <a:avLst/>
+          </a:prstGeom>
+        </p:spPr>
+      </p:pic>
+      <p:sp>
+        <p:nvSpPr>
+          <p:cNvPr id="6" name="TextBox 5"/>
           <p:cNvSpPr txBox="1"/>
           <p:nvPr/>
         </p:nvSpPr>
         <p:spPr>
           <a:xfrm>
-            <a:off x="777240" y="1691640"/>
-            <a:ext cx="5120640" cy="4572000"/>
+            <a:off x="8412480" y="1554480"/>
+            <a:ext cx="3474720" cy="685800"/>
+          </a:xfrm>
+          <a:prstGeom prst="rect">
+            <a:avLst/>
+          </a:prstGeom>
+          <a:noFill/>
+        </p:spPr>
+        <p:txBody>
+          <a:bodyPr wrap="square" lIns="0" rIns="0" tIns="0" bIns="0" anchor="b">
+            <a:spAutoFit/>
+          </a:bodyPr>
+          <a:lstStyle/>
+          <a:p>
+            <a:pPr algn="l">
+              <a:lnSpc>
+                <a:spcPct val="112000"/>
+              </a:lnSpc>
+              <a:spcAft>
+                <a:spcPts val="0"/>
+              </a:spcAft>
+            </a:pPr>
+            <a:r>
+              <a:rPr sz="2800" b="0" i="0">
+                <a:solidFill>
+                  <a:srgbClr val="E08A3C"/>
+                </a:solidFill>
+                <a:latin typeface="Poppins Light"/>
+              </a:rPr>
+              <a:t>45%</a:t>
+            </a:r>
+          </a:p>
+        </p:txBody>
+      </p:sp>
+      <p:sp>
+        <p:nvSpPr>
+          <p:cNvPr id="7" name="TextBox 6"/>
+          <p:cNvSpPr txBox="1"/>
+          <p:nvPr/>
+        </p:nvSpPr>
+        <p:spPr>
+          <a:xfrm>
+            <a:off x="8412480" y="2304288"/>
+            <a:ext cx="3474720" cy="822960"/>
           </a:xfrm>
           <a:prstGeom prst="rect">
             <a:avLst/>
@@ -10320,110 +10535,76 @@
           <a:p>
             <a:pPr algn="l">
               <a:lnSpc>
+                <a:spcPct val="105000"/>
+              </a:lnSpc>
+              <a:spcAft>
+                <a:spcPts val="0"/>
+              </a:spcAft>
+            </a:pPr>
+            <a:r>
+              <a:rPr sz="1300" b="0" i="0">
+                <a:solidFill>
+                  <a:srgbClr val="A8A8A8"/>
+                </a:solidFill>
+                <a:latin typeface="Poppins Light"/>
+              </a:rPr>
+              <a:t>of the blind spot recovered by the hybrid alert (IMD rule alone: 1%)</a:t>
+            </a:r>
+          </a:p>
+        </p:txBody>
+      </p:sp>
+      <p:sp>
+        <p:nvSpPr>
+          <p:cNvPr id="8" name="TextBox 7"/>
+          <p:cNvSpPr txBox="1"/>
+          <p:nvPr/>
+        </p:nvSpPr>
+        <p:spPr>
+          <a:xfrm>
+            <a:off x="8412480" y="3063240"/>
+            <a:ext cx="3474720" cy="685800"/>
+          </a:xfrm>
+          <a:prstGeom prst="rect">
+            <a:avLst/>
+          </a:prstGeom>
+          <a:noFill/>
+        </p:spPr>
+        <p:txBody>
+          <a:bodyPr wrap="square" lIns="0" rIns="0" tIns="0" bIns="0" anchor="b">
+            <a:spAutoFit/>
+          </a:bodyPr>
+          <a:lstStyle/>
+          <a:p>
+            <a:pPr algn="l">
+              <a:lnSpc>
                 <a:spcPct val="112000"/>
               </a:lnSpc>
               <a:spcAft>
-                <a:spcPts val="900"/>
-              </a:spcAft>
-            </a:pPr>
-            <a:r>
-              <a:rPr sz="1400" b="0" i="0">
+                <a:spcPts val="0"/>
+              </a:spcAft>
+            </a:pPr>
+            <a:r>
+              <a:rPr sz="2800" b="0" i="0">
                 <a:solidFill>
                   <a:srgbClr val="E08A3C"/>
                 </a:solidFill>
-                <a:latin typeface="Poppins"/>
-              </a:rPr>
-              <a:t>Limitations</a:t>
-            </a:r>
-          </a:p>
-          <a:p>
-            <a:pPr algn="l">
-              <a:lnSpc>
-                <a:spcPct val="112000"/>
-              </a:lnSpc>
-              <a:spcAft>
-                <a:spcPts val="900"/>
-              </a:spcAft>
-            </a:pPr>
-            <a:r>
-              <a:rPr sz="1400" b="0" i="0">
-                <a:solidFill>
-                  <a:srgbClr val="F2F2F2"/>
-                </a:solidFill>
-                <a:latin typeface="Poppins Light"/>
-              </a:rPr>
-              <a:t>ERA5's 0.25° grid smooths peaks: only 2 grid-days reached 31 °C; Mumbai's cell is sea-moderated</a:t>
-            </a:r>
-          </a:p>
-          <a:p>
-            <a:pPr algn="l">
-              <a:lnSpc>
-                <a:spcPct val="112000"/>
-              </a:lnSpc>
-              <a:spcAft>
-                <a:spcPts val="900"/>
-              </a:spcAft>
-            </a:pPr>
-            <a:r>
-              <a:rPr sz="1400" b="0" i="0">
-                <a:solidFill>
-                  <a:srgbClr val="F2F2F2"/>
-                </a:solidFill>
-                <a:latin typeface="Poppins Light"/>
-              </a:rPr>
-              <a:t>One grid cell stands in for IMD's two stations, which flatters IMD, so our miss rates are lower bounds</a:t>
-            </a:r>
-          </a:p>
-          <a:p>
-            <a:pPr algn="l">
-              <a:lnSpc>
-                <a:spcPct val="112000"/>
-              </a:lnSpc>
-              <a:spcAft>
-                <a:spcPts val="900"/>
-              </a:spcAft>
-            </a:pPr>
-            <a:r>
-              <a:rPr sz="1400" b="0" i="0">
-                <a:solidFill>
-                  <a:srgbClr val="F2F2F2"/>
-                </a:solidFill>
-                <a:latin typeface="Poppins Light"/>
-              </a:rPr>
-              <a:t>Thresholds come from young, healthy adults; older people and outdoor workers are at risk sooner</a:t>
-            </a:r>
-          </a:p>
-          <a:p>
-            <a:pPr algn="l">
-              <a:lnSpc>
-                <a:spcPct val="112000"/>
-              </a:lnSpc>
-              <a:spcAft>
-                <a:spcPts val="900"/>
-              </a:spcAft>
-            </a:pPr>
-            <a:r>
-              <a:rPr sz="1400" b="0" i="0">
-                <a:solidFill>
-                  <a:srgbClr val="F2F2F2"/>
-                </a:solidFill>
-                <a:latin typeface="Poppins Light"/>
-              </a:rPr>
-              <a:t>Day-level tests are approximate under autocorrelation (mitigated with block bootstrap and Markov models)</a:t>
-            </a:r>
-          </a:p>
-        </p:txBody>
-      </p:sp>
-      <p:sp>
-        <p:nvSpPr>
-          <p:cNvPr id="6" name="TextBox 5"/>
+                <a:latin typeface="Poppins Light"/>
+              </a:rPr>
+              <a:t>47%</a:t>
+            </a:r>
+          </a:p>
+        </p:txBody>
+      </p:sp>
+      <p:sp>
+        <p:nvSpPr>
+          <p:cNvPr id="9" name="TextBox 8"/>
           <p:cNvSpPr txBox="1"/>
           <p:nvPr/>
         </p:nvSpPr>
         <p:spPr>
           <a:xfrm>
-            <a:off x="6263640" y="1691640"/>
-            <a:ext cx="5120640" cy="4572000"/>
+            <a:off x="8412480" y="3813048"/>
+            <a:ext cx="3474720" cy="822960"/>
           </a:xfrm>
           <a:prstGeom prst="rect">
             <a:avLst/>
@@ -10438,96 +10619,146 @@
           <a:p>
             <a:pPr algn="l">
               <a:lnSpc>
+                <a:spcPct val="105000"/>
+              </a:lnSpc>
+              <a:spcAft>
+                <a:spcPts val="0"/>
+              </a:spcAft>
+            </a:pPr>
+            <a:r>
+              <a:rPr sz="1300" b="0" i="0">
+                <a:solidFill>
+                  <a:srgbClr val="A8A8A8"/>
+                </a:solidFill>
+                <a:latin typeface="Poppins Light"/>
+              </a:rPr>
+              <a:t>of next-day danger days caught (IMD rule: 4%)</a:t>
+            </a:r>
+          </a:p>
+        </p:txBody>
+      </p:sp>
+      <p:sp>
+        <p:nvSpPr>
+          <p:cNvPr id="10" name="TextBox 9"/>
+          <p:cNvSpPr txBox="1"/>
+          <p:nvPr/>
+        </p:nvSpPr>
+        <p:spPr>
+          <a:xfrm>
+            <a:off x="8412480" y="4572000"/>
+            <a:ext cx="3474720" cy="685800"/>
+          </a:xfrm>
+          <a:prstGeom prst="rect">
+            <a:avLst/>
+          </a:prstGeom>
+          <a:noFill/>
+        </p:spPr>
+        <p:txBody>
+          <a:bodyPr wrap="square" lIns="0" rIns="0" tIns="0" bIns="0" anchor="b">
+            <a:spAutoFit/>
+          </a:bodyPr>
+          <a:lstStyle/>
+          <a:p>
+            <a:pPr algn="l">
+              <a:lnSpc>
                 <a:spcPct val="112000"/>
               </a:lnSpc>
               <a:spcAft>
-                <a:spcPts val="900"/>
+                <a:spcPts val="0"/>
+              </a:spcAft>
+            </a:pPr>
+            <a:r>
+              <a:rPr sz="2800" b="0" i="0">
+                <a:solidFill>
+                  <a:srgbClr val="E08A3C"/>
+                </a:solidFill>
+                <a:latin typeface="Poppins Light"/>
+              </a:rPr>
+              <a:t>0.93 / 0.94</a:t>
+            </a:r>
+          </a:p>
+        </p:txBody>
+      </p:sp>
+      <p:sp>
+        <p:nvSpPr>
+          <p:cNvPr id="11" name="TextBox 10"/>
+          <p:cNvSpPr txBox="1"/>
+          <p:nvPr/>
+        </p:nvSpPr>
+        <p:spPr>
+          <a:xfrm>
+            <a:off x="8412480" y="5321808"/>
+            <a:ext cx="3474720" cy="822960"/>
+          </a:xfrm>
+          <a:prstGeom prst="rect">
+            <a:avLst/>
+          </a:prstGeom>
+          <a:noFill/>
+        </p:spPr>
+        <p:txBody>
+          <a:bodyPr wrap="square" lIns="0" rIns="0" tIns="0" bIns="0" anchor="t">
+            <a:spAutoFit/>
+          </a:bodyPr>
+          <a:lstStyle/>
+          <a:p>
+            <a:pPr algn="l">
+              <a:lnSpc>
+                <a:spcPct val="105000"/>
+              </a:lnSpc>
+              <a:spcAft>
+                <a:spcPts val="0"/>
+              </a:spcAft>
+            </a:pPr>
+            <a:r>
+              <a:rPr sz="1300" b="0" i="0">
+                <a:solidFill>
+                  <a:srgbClr val="A8A8A8"/>
+                </a:solidFill>
+                <a:latin typeface="Poppins Light"/>
+              </a:rPr>
+              <a:t>mean AUC in an unseen city / a trained city</a:t>
+            </a:r>
+          </a:p>
+        </p:txBody>
+      </p:sp>
+      <p:sp>
+        <p:nvSpPr>
+          <p:cNvPr id="12" name="TextBox 11"/>
+          <p:cNvSpPr txBox="1"/>
+          <p:nvPr/>
+        </p:nvSpPr>
+        <p:spPr>
+          <a:xfrm>
+            <a:off x="777240" y="5760720"/>
+            <a:ext cx="7315200" cy="731520"/>
+          </a:xfrm>
+          <a:prstGeom prst="rect">
+            <a:avLst/>
+          </a:prstGeom>
+          <a:noFill/>
+        </p:spPr>
+        <p:txBody>
+          <a:bodyPr wrap="square" lIns="0" rIns="0" tIns="0" bIns="0" anchor="t">
+            <a:spAutoFit/>
+          </a:bodyPr>
+          <a:lstStyle/>
+          <a:p>
+            <a:pPr algn="l">
+              <a:lnSpc>
+                <a:spcPct val="112000"/>
+              </a:lnSpc>
+              <a:spcAft>
+                <a:spcPts val="0"/>
               </a:spcAft>
             </a:pPr>
             <a:r>
               <a:rPr sz="1400" b="0" i="0">
                 <a:solidFill>
-                  <a:srgbClr val="E08A3C"/>
-                </a:solidFill>
-                <a:latin typeface="Poppins"/>
-              </a:rPr>
-              <a:t>Future work</a:t>
-            </a:r>
-          </a:p>
-          <a:p>
-            <a:pPr algn="l">
-              <a:lnSpc>
-                <a:spcPct val="112000"/>
-              </a:lnSpc>
-              <a:spcAft>
-                <a:spcPts val="900"/>
-              </a:spcAft>
-            </a:pPr>
-            <a:r>
-              <a:rPr sz="1400" b="0" i="0">
-                <a:solidFill>
-                  <a:srgbClr val="F2F2F2"/>
-                </a:solidFill>
-                <a:latin typeface="Poppins Light"/>
-              </a:rPr>
-              <a:t>Repeat with IMD station observations and finer reanalysis (ERA5-Land, IMDAA)</a:t>
-            </a:r>
-          </a:p>
-          <a:p>
-            <a:pPr algn="l">
-              <a:lnSpc>
-                <a:spcPct val="112000"/>
-              </a:lnSpc>
-              <a:spcAft>
-                <a:spcPts val="900"/>
-              </a:spcAft>
-            </a:pPr>
-            <a:r>
-              <a:rPr sz="1400" b="0" i="0">
-                <a:solidFill>
-                  <a:srgbClr val="F2F2F2"/>
-                </a:solidFill>
-                <a:latin typeface="Poppins Light"/>
-              </a:rPr>
-              <a:t>Link to hospital or mortality records to calibrate thresholds by age and occupation</a:t>
-            </a:r>
-          </a:p>
-          <a:p>
-            <a:pPr algn="l">
-              <a:lnSpc>
-                <a:spcPct val="112000"/>
-              </a:lnSpc>
-              <a:spcAft>
-                <a:spcPts val="900"/>
-              </a:spcAft>
-            </a:pPr>
-            <a:r>
-              <a:rPr sz="1400" b="0" i="0">
-                <a:solidFill>
-                  <a:srgbClr val="F2F2F2"/>
-                </a:solidFill>
-                <a:latin typeface="Poppins Light"/>
-              </a:rPr>
-              <a:t>Extend to warm nights and multi-day cumulative heat load</a:t>
-            </a:r>
-          </a:p>
-          <a:p>
-            <a:pPr algn="l">
-              <a:lnSpc>
-                <a:spcPct val="112000"/>
-              </a:lnSpc>
-              <a:spcAft>
-                <a:spcPts val="900"/>
-              </a:spcAft>
-            </a:pPr>
-            <a:r>
-              <a:rPr sz="1400" b="0" i="0">
-                <a:solidFill>
-                  <a:srgbClr val="F2F2F2"/>
-                </a:solidFill>
-                <a:latin typeface="Poppins Light"/>
-              </a:rPr>
-              <a:t>Operational district-level forecasts using weather-model inputs instead of today's observations</a:t>
+                  <a:srgbClr val="A8A8A8"/>
+                </a:solidFill>
+                <a:latin typeface="Poppins Light"/>
+              </a:rPr>
+              <a:t>Honest cost: 64% of hybrid alerts are false alarms. That suits a cheap hydrate-and-rest advisory, not school closures.</a:t>
             </a:r>
           </a:p>
         </p:txBody>
@@ -10552,7 +10783,7 @@
       <p:grpSpPr/>
       <p:pic>
         <p:nvPicPr>
-          <p:cNvPr id="2" name="Picture 1" descr="bg_content_d.jpg"/>
+          <p:cNvPr id="2" name="Picture 1" descr="bg_content_e_dim.jpg"/>
           <p:cNvPicPr>
             <a:picLocks noChangeAspect="1"/>
           </p:cNvPicPr>
@@ -10611,7 +10842,7 @@
                 </a:solidFill>
                 <a:latin typeface="Poppins Light"/>
               </a:rPr>
-              <a:t>REFERENCES</a:t>
+              <a:t>SHINY DASHBOARD: THE GAP IN ONE SCREEN</a:t>
             </a:r>
           </a:p>
         </p:txBody>
@@ -10659,16 +10890,45 @@
           </a:p>
         </p:txBody>
       </p:sp>
-      <p:sp>
-        <p:nvSpPr>
-          <p:cNvPr id="5" name="TextBox 4"/>
+      <p:pic>
+        <p:nvPicPr>
+          <p:cNvPr id="5" name="Picture 4" descr="dashboard_risk_crop.png"/>
+          <p:cNvPicPr>
+            <a:picLocks noChangeAspect="1"/>
+          </p:cNvPicPr>
+          <p:nvPr/>
+        </p:nvPicPr>
+        <p:blipFill>
+          <a:blip r:embed="rId4"/>
+          <a:stretch>
+            <a:fillRect/>
+          </a:stretch>
+        </p:blipFill>
+        <p:spPr>
+          <a:xfrm>
+            <a:off x="777240" y="1554480"/>
+            <a:ext cx="10607040" cy="3778758"/>
+          </a:xfrm>
+          <a:prstGeom prst="rect">
+            <a:avLst/>
+          </a:prstGeom>
+          <a:ln w="12700">
+            <a:solidFill>
+              <a:srgbClr val="444444"/>
+            </a:solidFill>
+          </a:ln>
+        </p:spPr>
+      </p:pic>
+      <p:sp>
+        <p:nvSpPr>
+          <p:cNvPr id="6" name="TextBox 5"/>
           <p:cNvSpPr txBox="1"/>
           <p:nvPr/>
         </p:nvSpPr>
         <p:spPr>
           <a:xfrm>
-            <a:off x="777240" y="1600200"/>
-            <a:ext cx="10789920" cy="4937760"/>
+            <a:off x="777240" y="5504688"/>
+            <a:ext cx="10607040" cy="365760"/>
           </a:xfrm>
           <a:prstGeom prst="rect">
             <a:avLst/>
@@ -10683,153 +10943,62 @@
           <a:p>
             <a:pPr algn="l">
               <a:lnSpc>
-                <a:spcPct val="108000"/>
-              </a:lnSpc>
-              <a:spcAft>
-                <a:spcPts val="900"/>
-              </a:spcAft>
-            </a:pPr>
-            <a:r>
-              <a:rPr sz="1350" b="0" i="0">
+                <a:spcPct val="112000"/>
+              </a:lnSpc>
+              <a:spcAft>
+                <a:spcPts val="0"/>
+              </a:spcAft>
+            </a:pPr>
+            <a:r>
+              <a:rPr sz="1400" b="0" i="0">
                 <a:solidFill>
                   <a:srgbClr val="F2F2F2"/>
                 </a:solidFill>
                 <a:latin typeface="Poppins Light"/>
               </a:rPr>
-              <a:t>India Meteorological Department. Criteria for heat wave; experimental Heat Index guidance.</a:t>
-            </a:r>
-          </a:p>
-          <a:p>
-            <a:pPr algn="l">
-              <a:lnSpc>
-                <a:spcPct val="108000"/>
-              </a:lnSpc>
-              <a:spcAft>
-                <a:spcPts val="900"/>
-              </a:spcAft>
-            </a:pPr>
-            <a:r>
-              <a:rPr sz="1350" b="0" i="0">
-                <a:solidFill>
-                  <a:srgbClr val="F2F2F2"/>
-                </a:solidFill>
-                <a:latin typeface="Poppins Light"/>
-              </a:rPr>
-              <a:t>Pillai, A. V. &amp; Dalmia, T. (2023). How is India adapting to heatwaves? An assessment of heat action plans. Centre for Policy Research.</a:t>
-            </a:r>
-          </a:p>
-          <a:p>
-            <a:pPr algn="l">
-              <a:lnSpc>
-                <a:spcPct val="108000"/>
-              </a:lnSpc>
-              <a:spcAft>
-                <a:spcPts val="900"/>
-              </a:spcAft>
-            </a:pPr>
-            <a:r>
-              <a:rPr sz="1350" b="0" i="0">
-                <a:solidFill>
-                  <a:srgbClr val="F2F2F2"/>
-                </a:solidFill>
-                <a:latin typeface="Poppins Light"/>
-              </a:rPr>
-              <a:t>Vecellio, D. J. et al. (2022). Evaluating the 35 °C wet-bulb temperature adaptability threshold for young, healthy subjects. J. Appl. Physiol. 132(2).</a:t>
-            </a:r>
-          </a:p>
-          <a:p>
-            <a:pPr algn="l">
-              <a:lnSpc>
-                <a:spcPct val="108000"/>
-              </a:lnSpc>
-              <a:spcAft>
-                <a:spcPts val="900"/>
-              </a:spcAft>
-            </a:pPr>
-            <a:r>
-              <a:rPr sz="1350" b="0" i="0">
-                <a:solidFill>
-                  <a:srgbClr val="F2F2F2"/>
-                </a:solidFill>
-                <a:latin typeface="Poppins Light"/>
-              </a:rPr>
-              <a:t>Raymond, C., Matthews, T. &amp; Horton, R. M. (2020). The emergence of heat and humidity too severe for human tolerance. Science Advances 6(19).</a:t>
-            </a:r>
-          </a:p>
-          <a:p>
-            <a:pPr algn="l">
-              <a:lnSpc>
-                <a:spcPct val="108000"/>
-              </a:lnSpc>
-              <a:spcAft>
-                <a:spcPts val="900"/>
-              </a:spcAft>
-            </a:pPr>
-            <a:r>
-              <a:rPr sz="1350" b="0" i="0">
-                <a:solidFill>
-                  <a:srgbClr val="F2F2F2"/>
-                </a:solidFill>
-                <a:latin typeface="Poppins Light"/>
-              </a:rPr>
-              <a:t>Stull, R. (2011). Wet-bulb temperature from relative humidity and air temperature. J. Appl. Meteor. Climatol. 50.</a:t>
-            </a:r>
-          </a:p>
-          <a:p>
-            <a:pPr algn="l">
-              <a:lnSpc>
-                <a:spcPct val="108000"/>
-              </a:lnSpc>
-              <a:spcAft>
-                <a:spcPts val="900"/>
-              </a:spcAft>
-            </a:pPr>
-            <a:r>
-              <a:rPr sz="1350" b="0" i="0">
-                <a:solidFill>
-                  <a:srgbClr val="F2F2F2"/>
-                </a:solidFill>
-                <a:latin typeface="Poppins Light"/>
-              </a:rPr>
-              <a:t>Coles, S. (2001). An Introduction to Statistical Modeling of Extreme Values. Springer.</a:t>
-            </a:r>
-          </a:p>
-          <a:p>
-            <a:pPr algn="l">
-              <a:lnSpc>
-                <a:spcPct val="108000"/>
-              </a:lnSpc>
-              <a:spcAft>
-                <a:spcPts val="900"/>
-              </a:spcAft>
-            </a:pPr>
-            <a:r>
-              <a:rPr sz="1350" b="0" i="0">
-                <a:solidFill>
-                  <a:srgbClr val="F2F2F2"/>
-                </a:solidFill>
-                <a:latin typeface="Poppins Light"/>
-              </a:rPr>
-              <a:t>Hersbach, H. et al. (2020). The ERA5 global reanalysis. QJRMS 146; accessed via Open-Meteo (CC BY 4.0).</a:t>
-            </a:r>
-          </a:p>
-          <a:p>
-            <a:pPr algn="l">
-              <a:lnSpc>
-                <a:spcPct val="108000"/>
-              </a:lnSpc>
-              <a:spcAft>
-                <a:spcPts val="900"/>
-              </a:spcAft>
-            </a:pPr>
-            <a:r>
-              <a:rPr sz="1350" b="0" i="0">
-                <a:solidFill>
-                  <a:srgbClr val="F2F2F2"/>
-                </a:solidFill>
-                <a:latin typeface="Poppins Light"/>
-              </a:rPr>
-              <a:t>Mann (1945); Sen (1968); DeLong et al. (1988), comparing correlated ROC curves.</a:t>
+              <a:t>Risk calculator, Kolkata on 20 May: the IMD rule says NO ALERT, the wet-bulb (30.7 °C) says DANGER, and the model gives 99% for tomorrow.</a:t>
+            </a:r>
+          </a:p>
+        </p:txBody>
+      </p:sp>
+      <p:sp>
+        <p:nvSpPr>
+          <p:cNvPr id="7" name="TextBox 6"/>
+          <p:cNvSpPr txBox="1"/>
+          <p:nvPr/>
+        </p:nvSpPr>
+        <p:spPr>
+          <a:xfrm>
+            <a:off x="777240" y="6199632"/>
+            <a:ext cx="10607040" cy="365760"/>
+          </a:xfrm>
+          <a:prstGeom prst="rect">
+            <a:avLst/>
+          </a:prstGeom>
+          <a:noFill/>
+        </p:spPr>
+        <p:txBody>
+          <a:bodyPr wrap="square" lIns="0" rIns="0" tIns="0" bIns="0" anchor="t">
+            <a:spAutoFit/>
+          </a:bodyPr>
+          <a:lstStyle/>
+          <a:p>
+            <a:pPr algn="l">
+              <a:lnSpc>
+                <a:spcPct val="112000"/>
+              </a:lnSpc>
+              <a:spcAft>
+                <a:spcPts val="0"/>
+              </a:spcAft>
+            </a:pPr>
+            <a:r>
+              <a:rPr sz="1300" b="0" i="0">
+                <a:solidFill>
+                  <a:srgbClr val="A8A8A8"/>
+                </a:solidFill>
+                <a:latin typeface="Poppins Light"/>
+              </a:rPr>
+              <a:t>Rscript -e 'shiny::runApp("app")'  ·  5 tabs: blind spot, trends, extremes, risk calculator, about</a:t>
             </a:r>
           </a:p>
         </p:txBody>
@@ -10843,6 +11012,1536 @@
 </file>
 
 <file path=ppt/slides/slide24.xml><?xml version="1.0" encoding="utf-8"?>
+<p:sld xmlns:a="http://schemas.openxmlformats.org/drawingml/2006/main" xmlns:p="http://schemas.openxmlformats.org/presentationml/2006/main" xmlns:r="http://schemas.openxmlformats.org/officeDocument/2006/relationships">
+  <p:cSld>
+    <p:spTree>
+      <p:nvGrpSpPr>
+        <p:cNvPr id="1" name=""/>
+        <p:cNvGrpSpPr/>
+        <p:nvPr/>
+      </p:nvGrpSpPr>
+      <p:grpSpPr/>
+      <p:pic>
+        <p:nvPicPr>
+          <p:cNvPr id="2" name="Picture 1" descr="bg_content_c.jpg"/>
+          <p:cNvPicPr>
+            <a:picLocks noChangeAspect="1"/>
+          </p:cNvPicPr>
+          <p:nvPr/>
+        </p:nvPicPr>
+        <p:blipFill>
+          <a:blip r:embed="rId2"/>
+          <a:stretch>
+            <a:fillRect/>
+          </a:stretch>
+        </p:blipFill>
+        <p:spPr>
+          <a:xfrm>
+            <a:off x="0" y="0"/>
+            <a:ext cx="12191695" cy="6858000"/>
+          </a:xfrm>
+          <a:prstGeom prst="rect">
+            <a:avLst/>
+          </a:prstGeom>
+        </p:spPr>
+      </p:pic>
+      <p:sp>
+        <p:nvSpPr>
+          <p:cNvPr id="3" name="Title"/>
+          <p:cNvSpPr txBox="1"/>
+          <p:nvPr/>
+        </p:nvSpPr>
+        <p:spPr>
+          <a:xfrm>
+            <a:off x="777240" y="502920"/>
+            <a:ext cx="10607040" cy="685800"/>
+          </a:xfrm>
+          <a:prstGeom prst="rect">
+            <a:avLst/>
+          </a:prstGeom>
+          <a:noFill/>
+        </p:spPr>
+        <p:txBody>
+          <a:bodyPr wrap="square" lIns="0" rIns="0" tIns="0" bIns="0" anchor="b">
+            <a:spAutoFit/>
+          </a:bodyPr>
+          <a:lstStyle/>
+          <a:p>
+            <a:pPr algn="l">
+              <a:lnSpc>
+                <a:spcPct val="112000"/>
+              </a:lnSpc>
+              <a:spcAft>
+                <a:spcPts val="0"/>
+              </a:spcAft>
+            </a:pPr>
+            <a:r>
+              <a:rPr sz="3400" b="0" i="0">
+                <a:solidFill>
+                  <a:srgbClr val="F2F2F2"/>
+                </a:solidFill>
+                <a:latin typeface="Poppins Light"/>
+              </a:rPr>
+              <a:t>CONCLUSIONS &amp; RECOMMENDATIONS</a:t>
+            </a:r>
+          </a:p>
+        </p:txBody>
+      </p:sp>
+      <p:sp>
+        <p:nvSpPr>
+          <p:cNvPr id="4" name="Title dash"/>
+          <p:cNvSpPr/>
+          <p:nvPr/>
+        </p:nvSpPr>
+        <p:spPr>
+          <a:xfrm>
+            <a:off x="777240" y="1344168"/>
+            <a:ext cx="384048" cy="27432"/>
+          </a:xfrm>
+          <a:prstGeom prst="rect">
+            <a:avLst/>
+          </a:prstGeom>
+          <a:solidFill>
+            <a:srgbClr val="D2B99A"/>
+          </a:solidFill>
+          <a:ln>
+            <a:noFill/>
+          </a:ln>
+        </p:spPr>
+        <p:style>
+          <a:lnRef idx="1">
+            <a:schemeClr val="accent1"/>
+          </a:lnRef>
+          <a:fillRef idx="3">
+            <a:schemeClr val="accent1"/>
+          </a:fillRef>
+          <a:effectRef idx="2">
+            <a:schemeClr val="accent1"/>
+          </a:effectRef>
+          <a:fontRef idx="minor">
+            <a:schemeClr val="lt1"/>
+          </a:fontRef>
+        </p:style>
+        <p:txBody>
+          <a:bodyPr rtlCol="0" anchor="ctr"/>
+          <a:lstStyle/>
+          <a:p>
+            <a:pPr algn="ctr"/>
+          </a:p>
+        </p:txBody>
+      </p:sp>
+      <p:sp>
+        <p:nvSpPr>
+          <p:cNvPr id="5" name="TextBox 4"/>
+          <p:cNvSpPr txBox="1"/>
+          <p:nvPr/>
+        </p:nvSpPr>
+        <p:spPr>
+          <a:xfrm>
+            <a:off x="777240" y="1600200"/>
+            <a:ext cx="822960" cy="411480"/>
+          </a:xfrm>
+          <a:prstGeom prst="rect">
+            <a:avLst/>
+          </a:prstGeom>
+          <a:noFill/>
+        </p:spPr>
+        <p:txBody>
+          <a:bodyPr wrap="square" lIns="0" rIns="0" tIns="0" bIns="0" anchor="t">
+            <a:spAutoFit/>
+          </a:bodyPr>
+          <a:lstStyle/>
+          <a:p>
+            <a:pPr algn="l">
+              <a:lnSpc>
+                <a:spcPct val="112000"/>
+              </a:lnSpc>
+              <a:spcAft>
+                <a:spcPts val="0"/>
+              </a:spcAft>
+            </a:pPr>
+            <a:r>
+              <a:rPr sz="1500" b="0" i="0">
+                <a:solidFill>
+                  <a:srgbClr val="E08A3C"/>
+                </a:solidFill>
+                <a:latin typeface="Poppins"/>
+              </a:rPr>
+              <a:t>RQ1</a:t>
+            </a:r>
+          </a:p>
+        </p:txBody>
+      </p:sp>
+      <p:sp>
+        <p:nvSpPr>
+          <p:cNvPr id="6" name="TextBox 5"/>
+          <p:cNvSpPr txBox="1"/>
+          <p:nvPr/>
+        </p:nvSpPr>
+        <p:spPr>
+          <a:xfrm>
+            <a:off x="1600200" y="1600200"/>
+            <a:ext cx="9692640" cy="411480"/>
+          </a:xfrm>
+          <a:prstGeom prst="rect">
+            <a:avLst/>
+          </a:prstGeom>
+          <a:noFill/>
+        </p:spPr>
+        <p:txBody>
+          <a:bodyPr wrap="square" lIns="0" rIns="0" tIns="0" bIns="0" anchor="t">
+            <a:spAutoFit/>
+          </a:bodyPr>
+          <a:lstStyle/>
+          <a:p>
+            <a:pPr algn="l">
+              <a:lnSpc>
+                <a:spcPct val="112000"/>
+              </a:lnSpc>
+              <a:spcAft>
+                <a:spcPts val="0"/>
+              </a:spcAft>
+            </a:pPr>
+            <a:r>
+              <a:rPr sz="1500" b="0" i="0">
+                <a:solidFill>
+                  <a:srgbClr val="F2F2F2"/>
+                </a:solidFill>
+                <a:latin typeface="Poppins Light"/>
+              </a:rPr>
+              <a:t>The IMD rule misses 96% of dangerous humid-heat days, in every city</a:t>
+            </a:r>
+          </a:p>
+        </p:txBody>
+      </p:sp>
+      <p:sp>
+        <p:nvSpPr>
+          <p:cNvPr id="7" name="TextBox 6"/>
+          <p:cNvSpPr txBox="1"/>
+          <p:nvPr/>
+        </p:nvSpPr>
+        <p:spPr>
+          <a:xfrm>
+            <a:off x="777240" y="2057400"/>
+            <a:ext cx="822960" cy="411480"/>
+          </a:xfrm>
+          <a:prstGeom prst="rect">
+            <a:avLst/>
+          </a:prstGeom>
+          <a:noFill/>
+        </p:spPr>
+        <p:txBody>
+          <a:bodyPr wrap="square" lIns="0" rIns="0" tIns="0" bIns="0" anchor="t">
+            <a:spAutoFit/>
+          </a:bodyPr>
+          <a:lstStyle/>
+          <a:p>
+            <a:pPr algn="l">
+              <a:lnSpc>
+                <a:spcPct val="112000"/>
+              </a:lnSpc>
+              <a:spcAft>
+                <a:spcPts val="0"/>
+              </a:spcAft>
+            </a:pPr>
+            <a:r>
+              <a:rPr sz="1500" b="0" i="0">
+                <a:solidFill>
+                  <a:srgbClr val="E08A3C"/>
+                </a:solidFill>
+                <a:latin typeface="Poppins"/>
+              </a:rPr>
+              <a:t>RQ2</a:t>
+            </a:r>
+          </a:p>
+        </p:txBody>
+      </p:sp>
+      <p:sp>
+        <p:nvSpPr>
+          <p:cNvPr id="8" name="TextBox 7"/>
+          <p:cNvSpPr txBox="1"/>
+          <p:nvPr/>
+        </p:nvSpPr>
+        <p:spPr>
+          <a:xfrm>
+            <a:off x="1600200" y="2057400"/>
+            <a:ext cx="9692640" cy="411480"/>
+          </a:xfrm>
+          <a:prstGeom prst="rect">
+            <a:avLst/>
+          </a:prstGeom>
+          <a:noFill/>
+        </p:spPr>
+        <p:txBody>
+          <a:bodyPr wrap="square" lIns="0" rIns="0" tIns="0" bIns="0" anchor="t">
+            <a:spAutoFit/>
+          </a:bodyPr>
+          <a:lstStyle/>
+          <a:p>
+            <a:pPr algn="l">
+              <a:lnSpc>
+                <a:spcPct val="112000"/>
+              </a:lnSpc>
+              <a:spcAft>
+                <a:spcPts val="0"/>
+              </a:spcAft>
+            </a:pPr>
+            <a:r>
+              <a:rPr sz="1500" b="0" i="0">
+                <a:solidFill>
+                  <a:srgbClr val="F2F2F2"/>
+                </a:solidFill>
+                <a:latin typeface="Poppins Light"/>
+              </a:rPr>
+              <a:t>Danger days grow ×1.54 per decade; Apr–Jun wet-bulb is up 0.53 °C</a:t>
+            </a:r>
+          </a:p>
+        </p:txBody>
+      </p:sp>
+      <p:sp>
+        <p:nvSpPr>
+          <p:cNvPr id="9" name="TextBox 8"/>
+          <p:cNvSpPr txBox="1"/>
+          <p:nvPr/>
+        </p:nvSpPr>
+        <p:spPr>
+          <a:xfrm>
+            <a:off x="777240" y="2514600"/>
+            <a:ext cx="822960" cy="411480"/>
+          </a:xfrm>
+          <a:prstGeom prst="rect">
+            <a:avLst/>
+          </a:prstGeom>
+          <a:noFill/>
+        </p:spPr>
+        <p:txBody>
+          <a:bodyPr wrap="square" lIns="0" rIns="0" tIns="0" bIns="0" anchor="t">
+            <a:spAutoFit/>
+          </a:bodyPr>
+          <a:lstStyle/>
+          <a:p>
+            <a:pPr algn="l">
+              <a:lnSpc>
+                <a:spcPct val="112000"/>
+              </a:lnSpc>
+              <a:spcAft>
+                <a:spcPts val="0"/>
+              </a:spcAft>
+            </a:pPr>
+            <a:r>
+              <a:rPr sz="1500" b="0" i="0">
+                <a:solidFill>
+                  <a:srgbClr val="E08A3C"/>
+                </a:solidFill>
+                <a:latin typeface="Poppins"/>
+              </a:rPr>
+              <a:t>RQ3</a:t>
+            </a:r>
+          </a:p>
+        </p:txBody>
+      </p:sp>
+      <p:sp>
+        <p:nvSpPr>
+          <p:cNvPr id="10" name="TextBox 9"/>
+          <p:cNvSpPr txBox="1"/>
+          <p:nvPr/>
+        </p:nvSpPr>
+        <p:spPr>
+          <a:xfrm>
+            <a:off x="1600200" y="2514600"/>
+            <a:ext cx="9692640" cy="411480"/>
+          </a:xfrm>
+          <a:prstGeom prst="rect">
+            <a:avLst/>
+          </a:prstGeom>
+          <a:noFill/>
+        </p:spPr>
+        <p:txBody>
+          <a:bodyPr wrap="square" lIns="0" rIns="0" tIns="0" bIns="0" anchor="t">
+            <a:spAutoFit/>
+          </a:bodyPr>
+          <a:lstStyle/>
+          <a:p>
+            <a:pPr algn="l">
+              <a:lnSpc>
+                <a:spcPct val="112000"/>
+              </a:lnSpc>
+              <a:spcAft>
+                <a:spcPts val="0"/>
+              </a:spcAft>
+            </a:pPr>
+            <a:r>
+              <a:rPr sz="1500" b="0" i="0">
+                <a:solidFill>
+                  <a:srgbClr val="F2F2F2"/>
+                </a:solidFill>
+                <a:latin typeface="Poppins Light"/>
+              </a:rPr>
+              <a:t>Tail shifting in 7/10 cities; Chennai's 1985 50-year extreme is now 1-in-2.6</a:t>
+            </a:r>
+          </a:p>
+        </p:txBody>
+      </p:sp>
+      <p:sp>
+        <p:nvSpPr>
+          <p:cNvPr id="11" name="TextBox 10"/>
+          <p:cNvSpPr txBox="1"/>
+          <p:nvPr/>
+        </p:nvSpPr>
+        <p:spPr>
+          <a:xfrm>
+            <a:off x="777240" y="2971800"/>
+            <a:ext cx="822960" cy="411480"/>
+          </a:xfrm>
+          <a:prstGeom prst="rect">
+            <a:avLst/>
+          </a:prstGeom>
+          <a:noFill/>
+        </p:spPr>
+        <p:txBody>
+          <a:bodyPr wrap="square" lIns="0" rIns="0" tIns="0" bIns="0" anchor="t">
+            <a:spAutoFit/>
+          </a:bodyPr>
+          <a:lstStyle/>
+          <a:p>
+            <a:pPr algn="l">
+              <a:lnSpc>
+                <a:spcPct val="112000"/>
+              </a:lnSpc>
+              <a:spcAft>
+                <a:spcPts val="0"/>
+              </a:spcAft>
+            </a:pPr>
+            <a:r>
+              <a:rPr sz="1500" b="0" i="0">
+                <a:solidFill>
+                  <a:srgbClr val="E08A3C"/>
+                </a:solidFill>
+                <a:latin typeface="Poppins"/>
+              </a:rPr>
+              <a:t>RQ4</a:t>
+            </a:r>
+          </a:p>
+        </p:txBody>
+      </p:sp>
+      <p:sp>
+        <p:nvSpPr>
+          <p:cNvPr id="12" name="TextBox 11"/>
+          <p:cNvSpPr txBox="1"/>
+          <p:nvPr/>
+        </p:nvSpPr>
+        <p:spPr>
+          <a:xfrm>
+            <a:off x="1600200" y="2971800"/>
+            <a:ext cx="9692640" cy="411480"/>
+          </a:xfrm>
+          <a:prstGeom prst="rect">
+            <a:avLst/>
+          </a:prstGeom>
+          <a:noFill/>
+        </p:spPr>
+        <p:txBody>
+          <a:bodyPr wrap="square" lIns="0" rIns="0" tIns="0" bIns="0" anchor="t">
+            <a:spAutoFit/>
+          </a:bodyPr>
+          <a:lstStyle/>
+          <a:p>
+            <a:pPr algn="l">
+              <a:lnSpc>
+                <a:spcPct val="112000"/>
+              </a:lnSpc>
+              <a:spcAft>
+                <a:spcPts val="0"/>
+              </a:spcAft>
+            </a:pPr>
+            <a:r>
+              <a:rPr sz="1500" b="0" i="0">
+                <a:solidFill>
+                  <a:srgbClr val="F2F2F2"/>
+                </a:solidFill>
+                <a:latin typeface="Poppins Light"/>
+              </a:rPr>
+              <a:t>Danger persists in spells; 3-day spells are now far more likely</a:t>
+            </a:r>
+          </a:p>
+        </p:txBody>
+      </p:sp>
+      <p:sp>
+        <p:nvSpPr>
+          <p:cNvPr id="13" name="TextBox 12"/>
+          <p:cNvSpPr txBox="1"/>
+          <p:nvPr/>
+        </p:nvSpPr>
+        <p:spPr>
+          <a:xfrm>
+            <a:off x="777240" y="3429000"/>
+            <a:ext cx="822960" cy="411480"/>
+          </a:xfrm>
+          <a:prstGeom prst="rect">
+            <a:avLst/>
+          </a:prstGeom>
+          <a:noFill/>
+        </p:spPr>
+        <p:txBody>
+          <a:bodyPr wrap="square" lIns="0" rIns="0" tIns="0" bIns="0" anchor="t">
+            <a:spAutoFit/>
+          </a:bodyPr>
+          <a:lstStyle/>
+          <a:p>
+            <a:pPr algn="l">
+              <a:lnSpc>
+                <a:spcPct val="112000"/>
+              </a:lnSpc>
+              <a:spcAft>
+                <a:spcPts val="0"/>
+              </a:spcAft>
+            </a:pPr>
+            <a:r>
+              <a:rPr sz="1500" b="0" i="0">
+                <a:solidFill>
+                  <a:srgbClr val="E08A3C"/>
+                </a:solidFill>
+                <a:latin typeface="Poppins"/>
+              </a:rPr>
+              <a:t>RQ5</a:t>
+            </a:r>
+          </a:p>
+        </p:txBody>
+      </p:sp>
+      <p:sp>
+        <p:nvSpPr>
+          <p:cNvPr id="14" name="TextBox 13"/>
+          <p:cNvSpPr txBox="1"/>
+          <p:nvPr/>
+        </p:nvSpPr>
+        <p:spPr>
+          <a:xfrm>
+            <a:off x="1600200" y="3429000"/>
+            <a:ext cx="9692640" cy="411480"/>
+          </a:xfrm>
+          <a:prstGeom prst="rect">
+            <a:avLst/>
+          </a:prstGeom>
+          <a:noFill/>
+        </p:spPr>
+        <p:txBody>
+          <a:bodyPr wrap="square" lIns="0" rIns="0" tIns="0" bIns="0" anchor="t">
+            <a:spAutoFit/>
+          </a:bodyPr>
+          <a:lstStyle/>
+          <a:p>
+            <a:pPr algn="l">
+              <a:lnSpc>
+                <a:spcPct val="112000"/>
+              </a:lnSpc>
+              <a:spcAft>
+                <a:spcPts val="0"/>
+              </a:spcAft>
+            </a:pPr>
+            <a:r>
+              <a:rPr sz="1500" b="0" i="0">
+                <a:solidFill>
+                  <a:srgbClr val="F2F2F2"/>
+                </a:solidFill>
+                <a:latin typeface="Poppins Light"/>
+              </a:rPr>
+              <a:t>A logistic warning reaches AUC 0.92 vs 0.61, and is calibrated</a:t>
+            </a:r>
+          </a:p>
+        </p:txBody>
+      </p:sp>
+      <p:sp>
+        <p:nvSpPr>
+          <p:cNvPr id="15" name="TextBox 14"/>
+          <p:cNvSpPr txBox="1"/>
+          <p:nvPr/>
+        </p:nvSpPr>
+        <p:spPr>
+          <a:xfrm>
+            <a:off x="777240" y="3886200"/>
+            <a:ext cx="822960" cy="411480"/>
+          </a:xfrm>
+          <a:prstGeom prst="rect">
+            <a:avLst/>
+          </a:prstGeom>
+          <a:noFill/>
+        </p:spPr>
+        <p:txBody>
+          <a:bodyPr wrap="square" lIns="0" rIns="0" tIns="0" bIns="0" anchor="t">
+            <a:spAutoFit/>
+          </a:bodyPr>
+          <a:lstStyle/>
+          <a:p>
+            <a:pPr algn="l">
+              <a:lnSpc>
+                <a:spcPct val="112000"/>
+              </a:lnSpc>
+              <a:spcAft>
+                <a:spcPts val="0"/>
+              </a:spcAft>
+            </a:pPr>
+            <a:r>
+              <a:rPr sz="1500" b="0" i="0">
+                <a:solidFill>
+                  <a:srgbClr val="E08A3C"/>
+                </a:solidFill>
+                <a:latin typeface="Poppins"/>
+              </a:rPr>
+              <a:t>RQ6</a:t>
+            </a:r>
+          </a:p>
+        </p:txBody>
+      </p:sp>
+      <p:sp>
+        <p:nvSpPr>
+          <p:cNvPr id="16" name="TextBox 15"/>
+          <p:cNvSpPr txBox="1"/>
+          <p:nvPr/>
+        </p:nvSpPr>
+        <p:spPr>
+          <a:xfrm>
+            <a:off x="1600200" y="3886200"/>
+            <a:ext cx="9692640" cy="411480"/>
+          </a:xfrm>
+          <a:prstGeom prst="rect">
+            <a:avLst/>
+          </a:prstGeom>
+          <a:noFill/>
+        </p:spPr>
+        <p:txBody>
+          <a:bodyPr wrap="square" lIns="0" rIns="0" tIns="0" bIns="0" anchor="t">
+            <a:spAutoFit/>
+          </a:bodyPr>
+          <a:lstStyle/>
+          <a:p>
+            <a:pPr algn="l">
+              <a:lnSpc>
+                <a:spcPct val="112000"/>
+              </a:lnSpc>
+              <a:spcAft>
+                <a:spcPts val="0"/>
+              </a:spcAft>
+            </a:pPr>
+            <a:r>
+              <a:rPr sz="1500" b="0" i="0">
+                <a:solidFill>
+                  <a:srgbClr val="F2F2F2"/>
+                </a:solidFill>
+                <a:latin typeface="Poppins Light"/>
+              </a:rPr>
+              <a:t>A random forest reaches AUC 0.95, recovers 45% of the blind spot, and transfers to unseen cities</a:t>
+            </a:r>
+          </a:p>
+        </p:txBody>
+      </p:sp>
+      <p:cxnSp>
+        <p:nvCxnSpPr>
+          <p:cNvPr id="17" name="Arrow bullet"/>
+          <p:cNvCxnSpPr/>
+          <p:nvPr/>
+        </p:nvCxnSpPr>
+        <p:spPr>
+          <a:xfrm flipV="1">
+            <a:off x="777240" y="4603496"/>
+            <a:ext cx="155448" cy="155448"/>
+          </a:xfrm>
+          <a:prstGeom prst="line">
+            <a:avLst/>
+          </a:prstGeom>
+          <a:ln w="20320">
+            <a:solidFill>
+              <a:srgbClr val="E3F04F"/>
+            </a:solidFill>
+            <a:tailEnd type="triangle" w="sm" len="sm"/>
+          </a:ln>
+        </p:spPr>
+        <p:style>
+          <a:lnRef idx="2">
+            <a:schemeClr val="accent1"/>
+          </a:lnRef>
+          <a:fillRef idx="0">
+            <a:schemeClr val="accent1"/>
+          </a:fillRef>
+          <a:effectRef idx="1">
+            <a:schemeClr val="accent1"/>
+          </a:effectRef>
+          <a:fontRef idx="minor">
+            <a:schemeClr val="tx1"/>
+          </a:fontRef>
+        </p:style>
+      </p:cxnSp>
+      <p:sp>
+        <p:nvSpPr>
+          <p:cNvPr id="18" name="TextBox 17"/>
+          <p:cNvSpPr txBox="1"/>
+          <p:nvPr/>
+        </p:nvSpPr>
+        <p:spPr>
+          <a:xfrm>
+            <a:off x="1124712" y="4526280"/>
+            <a:ext cx="10442448" cy="548640"/>
+          </a:xfrm>
+          <a:prstGeom prst="rect">
+            <a:avLst/>
+          </a:prstGeom>
+          <a:noFill/>
+        </p:spPr>
+        <p:txBody>
+          <a:bodyPr wrap="square" lIns="0" rIns="0" tIns="0" bIns="0" anchor="t">
+            <a:spAutoFit/>
+          </a:bodyPr>
+          <a:lstStyle/>
+          <a:p>
+            <a:pPr algn="l">
+              <a:lnSpc>
+                <a:spcPct val="105000"/>
+              </a:lnSpc>
+              <a:spcAft>
+                <a:spcPts val="0"/>
+              </a:spcAft>
+            </a:pPr>
+            <a:r>
+              <a:rPr sz="1600" b="0" i="0">
+                <a:solidFill>
+                  <a:srgbClr val="F2F2F2"/>
+                </a:solidFill>
+                <a:latin typeface="Poppins Light"/>
+              </a:rPr>
+              <a:t>Add a humidity-aware trigger (wet-bulb or Heat Index) to heatwave declarations</a:t>
+            </a:r>
+          </a:p>
+        </p:txBody>
+      </p:sp>
+      <p:cxnSp>
+        <p:nvCxnSpPr>
+          <p:cNvPr id="19" name="Arrow bullet"/>
+          <p:cNvCxnSpPr/>
+          <p:nvPr/>
+        </p:nvCxnSpPr>
+        <p:spPr>
+          <a:xfrm flipV="1">
+            <a:off x="777240" y="5152136"/>
+            <a:ext cx="155448" cy="155448"/>
+          </a:xfrm>
+          <a:prstGeom prst="line">
+            <a:avLst/>
+          </a:prstGeom>
+          <a:ln w="20320">
+            <a:solidFill>
+              <a:srgbClr val="E3F04F"/>
+            </a:solidFill>
+            <a:tailEnd type="triangle" w="sm" len="sm"/>
+          </a:ln>
+        </p:spPr>
+        <p:style>
+          <a:lnRef idx="2">
+            <a:schemeClr val="accent1"/>
+          </a:lnRef>
+          <a:fillRef idx="0">
+            <a:schemeClr val="accent1"/>
+          </a:fillRef>
+          <a:effectRef idx="1">
+            <a:schemeClr val="accent1"/>
+          </a:effectRef>
+          <a:fontRef idx="minor">
+            <a:schemeClr val="tx1"/>
+          </a:fontRef>
+        </p:style>
+      </p:cxnSp>
+      <p:sp>
+        <p:nvSpPr>
+          <p:cNvPr id="20" name="TextBox 19"/>
+          <p:cNvSpPr txBox="1"/>
+          <p:nvPr/>
+        </p:nvSpPr>
+        <p:spPr>
+          <a:xfrm>
+            <a:off x="1124712" y="5074920"/>
+            <a:ext cx="10442448" cy="548640"/>
+          </a:xfrm>
+          <a:prstGeom prst="rect">
+            <a:avLst/>
+          </a:prstGeom>
+          <a:noFill/>
+        </p:spPr>
+        <p:txBody>
+          <a:bodyPr wrap="square" lIns="0" rIns="0" tIns="0" bIns="0" anchor="t">
+            <a:spAutoFit/>
+          </a:bodyPr>
+          <a:lstStyle/>
+          <a:p>
+            <a:pPr algn="l">
+              <a:lnSpc>
+                <a:spcPct val="105000"/>
+              </a:lnSpc>
+              <a:spcAft>
+                <a:spcPts val="0"/>
+              </a:spcAft>
+            </a:pPr>
+            <a:r>
+              <a:rPr sz="1600" b="0" i="0">
+                <a:solidFill>
+                  <a:srgbClr val="F2F2F2"/>
+                </a:solidFill>
+                <a:latin typeface="Poppins Light"/>
+              </a:rPr>
+              <a:t>Replace fixed national cut-offs with local, probabilistic thresholds and return periods</a:t>
+            </a:r>
+          </a:p>
+        </p:txBody>
+      </p:sp>
+      <p:cxnSp>
+        <p:nvCxnSpPr>
+          <p:cNvPr id="21" name="Arrow bullet"/>
+          <p:cNvCxnSpPr/>
+          <p:nvPr/>
+        </p:nvCxnSpPr>
+        <p:spPr>
+          <a:xfrm flipV="1">
+            <a:off x="777240" y="5700776"/>
+            <a:ext cx="155448" cy="155448"/>
+          </a:xfrm>
+          <a:prstGeom prst="line">
+            <a:avLst/>
+          </a:prstGeom>
+          <a:ln w="20320">
+            <a:solidFill>
+              <a:srgbClr val="E3F04F"/>
+            </a:solidFill>
+            <a:tailEnd type="triangle" w="sm" len="sm"/>
+          </a:ln>
+        </p:spPr>
+        <p:style>
+          <a:lnRef idx="2">
+            <a:schemeClr val="accent1"/>
+          </a:lnRef>
+          <a:fillRef idx="0">
+            <a:schemeClr val="accent1"/>
+          </a:fillRef>
+          <a:effectRef idx="1">
+            <a:schemeClr val="accent1"/>
+          </a:effectRef>
+          <a:fontRef idx="minor">
+            <a:schemeClr val="tx1"/>
+          </a:fontRef>
+        </p:style>
+      </p:cxnSp>
+      <p:sp>
+        <p:nvSpPr>
+          <p:cNvPr id="22" name="TextBox 21"/>
+          <p:cNvSpPr txBox="1"/>
+          <p:nvPr/>
+        </p:nvSpPr>
+        <p:spPr>
+          <a:xfrm>
+            <a:off x="1124712" y="5623560"/>
+            <a:ext cx="10442448" cy="548640"/>
+          </a:xfrm>
+          <a:prstGeom prst="rect">
+            <a:avLst/>
+          </a:prstGeom>
+          <a:noFill/>
+        </p:spPr>
+        <p:txBody>
+          <a:bodyPr wrap="square" lIns="0" rIns="0" tIns="0" bIns="0" anchor="t">
+            <a:spAutoFit/>
+          </a:bodyPr>
+          <a:lstStyle/>
+          <a:p>
+            <a:pPr algn="l">
+              <a:lnSpc>
+                <a:spcPct val="105000"/>
+              </a:lnSpc>
+              <a:spcAft>
+                <a:spcPts val="0"/>
+              </a:spcAft>
+            </a:pPr>
+            <a:r>
+              <a:rPr sz="1600" b="0" i="0">
+                <a:solidFill>
+                  <a:srgbClr val="F2F2F2"/>
+                </a:solidFill>
+                <a:latin typeface="Poppins Light"/>
+              </a:rPr>
+              <a:t>Prioritise Kolkata, Bhubaneswar, Visakhapatnam and Chennai, where silent days dominate</a:t>
+            </a:r>
+          </a:p>
+        </p:txBody>
+      </p:sp>
+    </p:spTree>
+  </p:cSld>
+  <p:clrMapOvr>
+    <a:masterClrMapping/>
+  </p:clrMapOvr>
+</p:sld>
+</file>
+
+<file path=ppt/slides/slide25.xml><?xml version="1.0" encoding="utf-8"?>
+<p:sld xmlns:a="http://schemas.openxmlformats.org/drawingml/2006/main" xmlns:p="http://schemas.openxmlformats.org/presentationml/2006/main" xmlns:r="http://schemas.openxmlformats.org/officeDocument/2006/relationships">
+  <p:cSld>
+    <p:spTree>
+      <p:nvGrpSpPr>
+        <p:cNvPr id="1" name=""/>
+        <p:cNvGrpSpPr/>
+        <p:nvPr/>
+      </p:nvGrpSpPr>
+      <p:grpSpPr/>
+      <p:pic>
+        <p:nvPicPr>
+          <p:cNvPr id="2" name="Picture 1" descr="bg_content_d.jpg"/>
+          <p:cNvPicPr>
+            <a:picLocks noChangeAspect="1"/>
+          </p:cNvPicPr>
+          <p:nvPr/>
+        </p:nvPicPr>
+        <p:blipFill>
+          <a:blip r:embed="rId2"/>
+          <a:stretch>
+            <a:fillRect/>
+          </a:stretch>
+        </p:blipFill>
+        <p:spPr>
+          <a:xfrm>
+            <a:off x="0" y="0"/>
+            <a:ext cx="12191695" cy="6858000"/>
+          </a:xfrm>
+          <a:prstGeom prst="rect">
+            <a:avLst/>
+          </a:prstGeom>
+        </p:spPr>
+      </p:pic>
+      <p:sp>
+        <p:nvSpPr>
+          <p:cNvPr id="3" name="Title"/>
+          <p:cNvSpPr txBox="1"/>
+          <p:nvPr/>
+        </p:nvSpPr>
+        <p:spPr>
+          <a:xfrm>
+            <a:off x="777240" y="502920"/>
+            <a:ext cx="10607040" cy="685800"/>
+          </a:xfrm>
+          <a:prstGeom prst="rect">
+            <a:avLst/>
+          </a:prstGeom>
+          <a:noFill/>
+        </p:spPr>
+        <p:txBody>
+          <a:bodyPr wrap="square" lIns="0" rIns="0" tIns="0" bIns="0" anchor="b">
+            <a:spAutoFit/>
+          </a:bodyPr>
+          <a:lstStyle/>
+          <a:p>
+            <a:pPr algn="l">
+              <a:lnSpc>
+                <a:spcPct val="112000"/>
+              </a:lnSpc>
+              <a:spcAft>
+                <a:spcPts val="0"/>
+              </a:spcAft>
+            </a:pPr>
+            <a:r>
+              <a:rPr sz="3400" b="0" i="0">
+                <a:solidFill>
+                  <a:srgbClr val="F2F2F2"/>
+                </a:solidFill>
+                <a:latin typeface="Poppins Light"/>
+              </a:rPr>
+              <a:t>LIMITATIONS &amp; FUTURE WORK</a:t>
+            </a:r>
+          </a:p>
+        </p:txBody>
+      </p:sp>
+      <p:sp>
+        <p:nvSpPr>
+          <p:cNvPr id="4" name="Title dash"/>
+          <p:cNvSpPr/>
+          <p:nvPr/>
+        </p:nvSpPr>
+        <p:spPr>
+          <a:xfrm>
+            <a:off x="777240" y="1344168"/>
+            <a:ext cx="384048" cy="27432"/>
+          </a:xfrm>
+          <a:prstGeom prst="rect">
+            <a:avLst/>
+          </a:prstGeom>
+          <a:solidFill>
+            <a:srgbClr val="D2B99A"/>
+          </a:solidFill>
+          <a:ln>
+            <a:noFill/>
+          </a:ln>
+        </p:spPr>
+        <p:style>
+          <a:lnRef idx="1">
+            <a:schemeClr val="accent1"/>
+          </a:lnRef>
+          <a:fillRef idx="3">
+            <a:schemeClr val="accent1"/>
+          </a:fillRef>
+          <a:effectRef idx="2">
+            <a:schemeClr val="accent1"/>
+          </a:effectRef>
+          <a:fontRef idx="minor">
+            <a:schemeClr val="lt1"/>
+          </a:fontRef>
+        </p:style>
+        <p:txBody>
+          <a:bodyPr rtlCol="0" anchor="ctr"/>
+          <a:lstStyle/>
+          <a:p>
+            <a:pPr algn="ctr"/>
+          </a:p>
+        </p:txBody>
+      </p:sp>
+      <p:sp>
+        <p:nvSpPr>
+          <p:cNvPr id="5" name="TextBox 4"/>
+          <p:cNvSpPr txBox="1"/>
+          <p:nvPr/>
+        </p:nvSpPr>
+        <p:spPr>
+          <a:xfrm>
+            <a:off x="777240" y="1691640"/>
+            <a:ext cx="5120640" cy="4572000"/>
+          </a:xfrm>
+          <a:prstGeom prst="rect">
+            <a:avLst/>
+          </a:prstGeom>
+          <a:noFill/>
+        </p:spPr>
+        <p:txBody>
+          <a:bodyPr wrap="square" lIns="0" rIns="0" tIns="0" bIns="0" anchor="t">
+            <a:spAutoFit/>
+          </a:bodyPr>
+          <a:lstStyle/>
+          <a:p>
+            <a:pPr algn="l">
+              <a:lnSpc>
+                <a:spcPct val="112000"/>
+              </a:lnSpc>
+              <a:spcAft>
+                <a:spcPts val="900"/>
+              </a:spcAft>
+            </a:pPr>
+            <a:r>
+              <a:rPr sz="1400" b="0" i="0">
+                <a:solidFill>
+                  <a:srgbClr val="E08A3C"/>
+                </a:solidFill>
+                <a:latin typeface="Poppins"/>
+              </a:rPr>
+              <a:t>Limitations</a:t>
+            </a:r>
+          </a:p>
+          <a:p>
+            <a:pPr algn="l">
+              <a:lnSpc>
+                <a:spcPct val="112000"/>
+              </a:lnSpc>
+              <a:spcAft>
+                <a:spcPts val="900"/>
+              </a:spcAft>
+            </a:pPr>
+            <a:r>
+              <a:rPr sz="1400" b="0" i="0">
+                <a:solidFill>
+                  <a:srgbClr val="F2F2F2"/>
+                </a:solidFill>
+                <a:latin typeface="Poppins Light"/>
+              </a:rPr>
+              <a:t>ERA5's 0.25° grid smooths peaks: only 2 grid-days reached 31 °C; Mumbai's cell is sea-moderated</a:t>
+            </a:r>
+          </a:p>
+          <a:p>
+            <a:pPr algn="l">
+              <a:lnSpc>
+                <a:spcPct val="112000"/>
+              </a:lnSpc>
+              <a:spcAft>
+                <a:spcPts val="900"/>
+              </a:spcAft>
+            </a:pPr>
+            <a:r>
+              <a:rPr sz="1400" b="0" i="0">
+                <a:solidFill>
+                  <a:srgbClr val="F2F2F2"/>
+                </a:solidFill>
+                <a:latin typeface="Poppins Light"/>
+              </a:rPr>
+              <a:t>One grid cell stands in for IMD's two stations, which flatters IMD, so our miss rates are lower bounds</a:t>
+            </a:r>
+          </a:p>
+          <a:p>
+            <a:pPr algn="l">
+              <a:lnSpc>
+                <a:spcPct val="112000"/>
+              </a:lnSpc>
+              <a:spcAft>
+                <a:spcPts val="900"/>
+              </a:spcAft>
+            </a:pPr>
+            <a:r>
+              <a:rPr sz="1400" b="0" i="0">
+                <a:solidFill>
+                  <a:srgbClr val="F2F2F2"/>
+                </a:solidFill>
+                <a:latin typeface="Poppins Light"/>
+              </a:rPr>
+              <a:t>Thresholds come from young, healthy adults; older people and outdoor workers are at risk sooner</a:t>
+            </a:r>
+          </a:p>
+          <a:p>
+            <a:pPr algn="l">
+              <a:lnSpc>
+                <a:spcPct val="112000"/>
+              </a:lnSpc>
+              <a:spcAft>
+                <a:spcPts val="900"/>
+              </a:spcAft>
+            </a:pPr>
+            <a:r>
+              <a:rPr sz="1400" b="0" i="0">
+                <a:solidFill>
+                  <a:srgbClr val="F2F2F2"/>
+                </a:solidFill>
+                <a:latin typeface="Poppins Light"/>
+              </a:rPr>
+              <a:t>Day-level tests are approximate under autocorrelation (mitigated with block bootstrap and Markov models)</a:t>
+            </a:r>
+          </a:p>
+        </p:txBody>
+      </p:sp>
+      <p:sp>
+        <p:nvSpPr>
+          <p:cNvPr id="6" name="TextBox 5"/>
+          <p:cNvSpPr txBox="1"/>
+          <p:nvPr/>
+        </p:nvSpPr>
+        <p:spPr>
+          <a:xfrm>
+            <a:off x="6263640" y="1691640"/>
+            <a:ext cx="5120640" cy="4572000"/>
+          </a:xfrm>
+          <a:prstGeom prst="rect">
+            <a:avLst/>
+          </a:prstGeom>
+          <a:noFill/>
+        </p:spPr>
+        <p:txBody>
+          <a:bodyPr wrap="square" lIns="0" rIns="0" tIns="0" bIns="0" anchor="t">
+            <a:spAutoFit/>
+          </a:bodyPr>
+          <a:lstStyle/>
+          <a:p>
+            <a:pPr algn="l">
+              <a:lnSpc>
+                <a:spcPct val="112000"/>
+              </a:lnSpc>
+              <a:spcAft>
+                <a:spcPts val="900"/>
+              </a:spcAft>
+            </a:pPr>
+            <a:r>
+              <a:rPr sz="1400" b="0" i="0">
+                <a:solidFill>
+                  <a:srgbClr val="E08A3C"/>
+                </a:solidFill>
+                <a:latin typeface="Poppins"/>
+              </a:rPr>
+              <a:t>Future work</a:t>
+            </a:r>
+          </a:p>
+          <a:p>
+            <a:pPr algn="l">
+              <a:lnSpc>
+                <a:spcPct val="112000"/>
+              </a:lnSpc>
+              <a:spcAft>
+                <a:spcPts val="900"/>
+              </a:spcAft>
+            </a:pPr>
+            <a:r>
+              <a:rPr sz="1400" b="0" i="0">
+                <a:solidFill>
+                  <a:srgbClr val="F2F2F2"/>
+                </a:solidFill>
+                <a:latin typeface="Poppins Light"/>
+              </a:rPr>
+              <a:t>Repeat with IMD station observations and finer reanalysis (ERA5-Land, IMDAA)</a:t>
+            </a:r>
+          </a:p>
+          <a:p>
+            <a:pPr algn="l">
+              <a:lnSpc>
+                <a:spcPct val="112000"/>
+              </a:lnSpc>
+              <a:spcAft>
+                <a:spcPts val="900"/>
+              </a:spcAft>
+            </a:pPr>
+            <a:r>
+              <a:rPr sz="1400" b="0" i="0">
+                <a:solidFill>
+                  <a:srgbClr val="F2F2F2"/>
+                </a:solidFill>
+                <a:latin typeface="Poppins Light"/>
+              </a:rPr>
+              <a:t>Link to hospital or mortality records to calibrate thresholds by age and occupation</a:t>
+            </a:r>
+          </a:p>
+          <a:p>
+            <a:pPr algn="l">
+              <a:lnSpc>
+                <a:spcPct val="112000"/>
+              </a:lnSpc>
+              <a:spcAft>
+                <a:spcPts val="900"/>
+              </a:spcAft>
+            </a:pPr>
+            <a:r>
+              <a:rPr sz="1400" b="0" i="0">
+                <a:solidFill>
+                  <a:srgbClr val="F2F2F2"/>
+                </a:solidFill>
+                <a:latin typeface="Poppins Light"/>
+              </a:rPr>
+              <a:t>Extend to warm nights and multi-day cumulative heat load</a:t>
+            </a:r>
+          </a:p>
+          <a:p>
+            <a:pPr algn="l">
+              <a:lnSpc>
+                <a:spcPct val="112000"/>
+              </a:lnSpc>
+              <a:spcAft>
+                <a:spcPts val="900"/>
+              </a:spcAft>
+            </a:pPr>
+            <a:r>
+              <a:rPr sz="1400" b="0" i="0">
+                <a:solidFill>
+                  <a:srgbClr val="F2F2F2"/>
+                </a:solidFill>
+                <a:latin typeface="Poppins Light"/>
+              </a:rPr>
+              <a:t>Operational district-level forecasts using weather-model inputs instead of today's observations</a:t>
+            </a:r>
+          </a:p>
+        </p:txBody>
+      </p:sp>
+    </p:spTree>
+  </p:cSld>
+  <p:clrMapOvr>
+    <a:masterClrMapping/>
+  </p:clrMapOvr>
+</p:sld>
+</file>
+
+<file path=ppt/slides/slide26.xml><?xml version="1.0" encoding="utf-8"?>
+<p:sld xmlns:a="http://schemas.openxmlformats.org/drawingml/2006/main" xmlns:p="http://schemas.openxmlformats.org/presentationml/2006/main" xmlns:r="http://schemas.openxmlformats.org/officeDocument/2006/relationships">
+  <p:cSld>
+    <p:spTree>
+      <p:nvGrpSpPr>
+        <p:cNvPr id="1" name=""/>
+        <p:cNvGrpSpPr/>
+        <p:nvPr/>
+      </p:nvGrpSpPr>
+      <p:grpSpPr/>
+      <p:pic>
+        <p:nvPicPr>
+          <p:cNvPr id="2" name="Picture 1" descr="bg_content_d.jpg"/>
+          <p:cNvPicPr>
+            <a:picLocks noChangeAspect="1"/>
+          </p:cNvPicPr>
+          <p:nvPr/>
+        </p:nvPicPr>
+        <p:blipFill>
+          <a:blip r:embed="rId2"/>
+          <a:stretch>
+            <a:fillRect/>
+          </a:stretch>
+        </p:blipFill>
+        <p:spPr>
+          <a:xfrm>
+            <a:off x="0" y="0"/>
+            <a:ext cx="12191695" cy="6858000"/>
+          </a:xfrm>
+          <a:prstGeom prst="rect">
+            <a:avLst/>
+          </a:prstGeom>
+        </p:spPr>
+      </p:pic>
+      <p:sp>
+        <p:nvSpPr>
+          <p:cNvPr id="3" name="Title"/>
+          <p:cNvSpPr txBox="1"/>
+          <p:nvPr/>
+        </p:nvSpPr>
+        <p:spPr>
+          <a:xfrm>
+            <a:off x="777240" y="502920"/>
+            <a:ext cx="10607040" cy="685800"/>
+          </a:xfrm>
+          <a:prstGeom prst="rect">
+            <a:avLst/>
+          </a:prstGeom>
+          <a:noFill/>
+        </p:spPr>
+        <p:txBody>
+          <a:bodyPr wrap="square" lIns="0" rIns="0" tIns="0" bIns="0" anchor="b">
+            <a:spAutoFit/>
+          </a:bodyPr>
+          <a:lstStyle/>
+          <a:p>
+            <a:pPr algn="l">
+              <a:lnSpc>
+                <a:spcPct val="112000"/>
+              </a:lnSpc>
+              <a:spcAft>
+                <a:spcPts val="0"/>
+              </a:spcAft>
+            </a:pPr>
+            <a:r>
+              <a:rPr sz="3400" b="0" i="0">
+                <a:solidFill>
+                  <a:srgbClr val="F2F2F2"/>
+                </a:solidFill>
+                <a:latin typeface="Poppins Light"/>
+              </a:rPr>
+              <a:t>REFERENCES</a:t>
+            </a:r>
+          </a:p>
+        </p:txBody>
+      </p:sp>
+      <p:sp>
+        <p:nvSpPr>
+          <p:cNvPr id="4" name="Title dash"/>
+          <p:cNvSpPr/>
+          <p:nvPr/>
+        </p:nvSpPr>
+        <p:spPr>
+          <a:xfrm>
+            <a:off x="777240" y="1344168"/>
+            <a:ext cx="384048" cy="27432"/>
+          </a:xfrm>
+          <a:prstGeom prst="rect">
+            <a:avLst/>
+          </a:prstGeom>
+          <a:solidFill>
+            <a:srgbClr val="D2B99A"/>
+          </a:solidFill>
+          <a:ln>
+            <a:noFill/>
+          </a:ln>
+        </p:spPr>
+        <p:style>
+          <a:lnRef idx="1">
+            <a:schemeClr val="accent1"/>
+          </a:lnRef>
+          <a:fillRef idx="3">
+            <a:schemeClr val="accent1"/>
+          </a:fillRef>
+          <a:effectRef idx="2">
+            <a:schemeClr val="accent1"/>
+          </a:effectRef>
+          <a:fontRef idx="minor">
+            <a:schemeClr val="lt1"/>
+          </a:fontRef>
+        </p:style>
+        <p:txBody>
+          <a:bodyPr rtlCol="0" anchor="ctr"/>
+          <a:lstStyle/>
+          <a:p>
+            <a:pPr algn="ctr"/>
+          </a:p>
+        </p:txBody>
+      </p:sp>
+      <p:sp>
+        <p:nvSpPr>
+          <p:cNvPr id="5" name="TextBox 4"/>
+          <p:cNvSpPr txBox="1"/>
+          <p:nvPr/>
+        </p:nvSpPr>
+        <p:spPr>
+          <a:xfrm>
+            <a:off x="777240" y="1600200"/>
+            <a:ext cx="10789920" cy="4937760"/>
+          </a:xfrm>
+          <a:prstGeom prst="rect">
+            <a:avLst/>
+          </a:prstGeom>
+          <a:noFill/>
+        </p:spPr>
+        <p:txBody>
+          <a:bodyPr wrap="square" lIns="0" rIns="0" tIns="0" bIns="0" anchor="t">
+            <a:spAutoFit/>
+          </a:bodyPr>
+          <a:lstStyle/>
+          <a:p>
+            <a:pPr algn="l">
+              <a:lnSpc>
+                <a:spcPct val="108000"/>
+              </a:lnSpc>
+              <a:spcAft>
+                <a:spcPts val="900"/>
+              </a:spcAft>
+            </a:pPr>
+            <a:r>
+              <a:rPr sz="1350" b="0" i="0">
+                <a:solidFill>
+                  <a:srgbClr val="F2F2F2"/>
+                </a:solidFill>
+                <a:latin typeface="Poppins Light"/>
+              </a:rPr>
+              <a:t>India Meteorological Department. Criteria for heat wave; experimental Heat Index guidance.</a:t>
+            </a:r>
+          </a:p>
+          <a:p>
+            <a:pPr algn="l">
+              <a:lnSpc>
+                <a:spcPct val="108000"/>
+              </a:lnSpc>
+              <a:spcAft>
+                <a:spcPts val="900"/>
+              </a:spcAft>
+            </a:pPr>
+            <a:r>
+              <a:rPr sz="1350" b="0" i="0">
+                <a:solidFill>
+                  <a:srgbClr val="F2F2F2"/>
+                </a:solidFill>
+                <a:latin typeface="Poppins Light"/>
+              </a:rPr>
+              <a:t>Pillai, A. V. &amp; Dalmia, T. (2023). How is India adapting to heatwaves? An assessment of heat action plans. Centre for Policy Research.</a:t>
+            </a:r>
+          </a:p>
+          <a:p>
+            <a:pPr algn="l">
+              <a:lnSpc>
+                <a:spcPct val="108000"/>
+              </a:lnSpc>
+              <a:spcAft>
+                <a:spcPts val="900"/>
+              </a:spcAft>
+            </a:pPr>
+            <a:r>
+              <a:rPr sz="1350" b="0" i="0">
+                <a:solidFill>
+                  <a:srgbClr val="F2F2F2"/>
+                </a:solidFill>
+                <a:latin typeface="Poppins Light"/>
+              </a:rPr>
+              <a:t>Vecellio, D. J. et al. (2022). Evaluating the 35 °C wet-bulb temperature adaptability threshold for young, healthy subjects. J. Appl. Physiol. 132(2).</a:t>
+            </a:r>
+          </a:p>
+          <a:p>
+            <a:pPr algn="l">
+              <a:lnSpc>
+                <a:spcPct val="108000"/>
+              </a:lnSpc>
+              <a:spcAft>
+                <a:spcPts val="900"/>
+              </a:spcAft>
+            </a:pPr>
+            <a:r>
+              <a:rPr sz="1350" b="0" i="0">
+                <a:solidFill>
+                  <a:srgbClr val="F2F2F2"/>
+                </a:solidFill>
+                <a:latin typeface="Poppins Light"/>
+              </a:rPr>
+              <a:t>Raymond, C., Matthews, T. &amp; Horton, R. M. (2020). The emergence of heat and humidity too severe for human tolerance. Science Advances 6(19).</a:t>
+            </a:r>
+          </a:p>
+          <a:p>
+            <a:pPr algn="l">
+              <a:lnSpc>
+                <a:spcPct val="108000"/>
+              </a:lnSpc>
+              <a:spcAft>
+                <a:spcPts val="900"/>
+              </a:spcAft>
+            </a:pPr>
+            <a:r>
+              <a:rPr sz="1350" b="0" i="0">
+                <a:solidFill>
+                  <a:srgbClr val="F2F2F2"/>
+                </a:solidFill>
+                <a:latin typeface="Poppins Light"/>
+              </a:rPr>
+              <a:t>Stull, R. (2011). Wet-bulb temperature from relative humidity and air temperature. J. Appl. Meteor. Climatol. 50.</a:t>
+            </a:r>
+          </a:p>
+          <a:p>
+            <a:pPr algn="l">
+              <a:lnSpc>
+                <a:spcPct val="108000"/>
+              </a:lnSpc>
+              <a:spcAft>
+                <a:spcPts val="900"/>
+              </a:spcAft>
+            </a:pPr>
+            <a:r>
+              <a:rPr sz="1350" b="0" i="0">
+                <a:solidFill>
+                  <a:srgbClr val="F2F2F2"/>
+                </a:solidFill>
+                <a:latin typeface="Poppins Light"/>
+              </a:rPr>
+              <a:t>Coles, S. (2001). An Introduction to Statistical Modeling of Extreme Values. Springer.</a:t>
+            </a:r>
+          </a:p>
+          <a:p>
+            <a:pPr algn="l">
+              <a:lnSpc>
+                <a:spcPct val="108000"/>
+              </a:lnSpc>
+              <a:spcAft>
+                <a:spcPts val="900"/>
+              </a:spcAft>
+            </a:pPr>
+            <a:r>
+              <a:rPr sz="1350" b="0" i="0">
+                <a:solidFill>
+                  <a:srgbClr val="F2F2F2"/>
+                </a:solidFill>
+                <a:latin typeface="Poppins Light"/>
+              </a:rPr>
+              <a:t>Hersbach, H. et al. (2020). The ERA5 global reanalysis. QJRMS 146; accessed via Open-Meteo (CC BY 4.0).</a:t>
+            </a:r>
+          </a:p>
+          <a:p>
+            <a:pPr algn="l">
+              <a:lnSpc>
+                <a:spcPct val="108000"/>
+              </a:lnSpc>
+              <a:spcAft>
+                <a:spcPts val="900"/>
+              </a:spcAft>
+            </a:pPr>
+            <a:r>
+              <a:rPr sz="1350" b="0" i="0">
+                <a:solidFill>
+                  <a:srgbClr val="F2F2F2"/>
+                </a:solidFill>
+                <a:latin typeface="Poppins Light"/>
+              </a:rPr>
+              <a:t>Mann (1945); Sen (1968); DeLong et al. (1988), comparing correlated ROC curves.</a:t>
+            </a:r>
+          </a:p>
+        </p:txBody>
+      </p:sp>
+    </p:spTree>
+  </p:cSld>
+  <p:clrMapOvr>
+    <a:masterClrMapping/>
+  </p:clrMapOvr>
+</p:sld>
+</file>
+
+<file path=ppt/slides/slide27.xml><?xml version="1.0" encoding="utf-8"?>
 <p:sld xmlns:a="http://schemas.openxmlformats.org/drawingml/2006/main" xmlns:p="http://schemas.openxmlformats.org/presentationml/2006/main" xmlns:r="http://schemas.openxmlformats.org/officeDocument/2006/relationships">
   <p:cSld>
     <p:spTree>
@@ -12067,7 +13766,7 @@
         </p:nvSpPr>
         <p:spPr>
           <a:xfrm>
-            <a:off x="777240" y="1783080"/>
+            <a:off x="777240" y="1645920"/>
             <a:ext cx="1005840" cy="548640"/>
           </a:xfrm>
           <a:prstGeom prst="rect">
@@ -12109,7 +13808,7 @@
         </p:nvSpPr>
         <p:spPr>
           <a:xfrm>
-            <a:off x="1874519" y="1764792"/>
+            <a:off x="1874519" y="1627632"/>
             <a:ext cx="9418320" cy="411480"/>
           </a:xfrm>
           <a:prstGeom prst="rect">
@@ -12151,7 +13850,7 @@
         </p:nvSpPr>
         <p:spPr>
           <a:xfrm>
-            <a:off x="1874519" y="2194560"/>
+            <a:off x="1874519" y="2057400"/>
             <a:ext cx="9418320" cy="365760"/>
           </a:xfrm>
           <a:prstGeom prst="rect">
@@ -12193,7 +13892,7 @@
         </p:nvSpPr>
         <p:spPr>
           <a:xfrm>
-            <a:off x="777240" y="2715768"/>
+            <a:off x="777240" y="2450592"/>
             <a:ext cx="1005840" cy="548640"/>
           </a:xfrm>
           <a:prstGeom prst="rect">
@@ -12235,7 +13934,7 @@
         </p:nvSpPr>
         <p:spPr>
           <a:xfrm>
-            <a:off x="1874519" y="2697479"/>
+            <a:off x="1874519" y="2432304"/>
             <a:ext cx="9418320" cy="411480"/>
           </a:xfrm>
           <a:prstGeom prst="rect">
@@ -12277,7 +13976,7 @@
         </p:nvSpPr>
         <p:spPr>
           <a:xfrm>
-            <a:off x="1874519" y="3127248"/>
+            <a:off x="1874519" y="2862072"/>
             <a:ext cx="9418320" cy="365760"/>
           </a:xfrm>
           <a:prstGeom prst="rect">
@@ -12319,7 +14018,7 @@
         </p:nvSpPr>
         <p:spPr>
           <a:xfrm>
-            <a:off x="777240" y="3648456"/>
+            <a:off x="777240" y="3255264"/>
             <a:ext cx="1005840" cy="548640"/>
           </a:xfrm>
           <a:prstGeom prst="rect">
@@ -12361,7 +14060,7 @@
         </p:nvSpPr>
         <p:spPr>
           <a:xfrm>
-            <a:off x="1874519" y="3630168"/>
+            <a:off x="1874519" y="3236976"/>
             <a:ext cx="9418320" cy="411480"/>
           </a:xfrm>
           <a:prstGeom prst="rect">
@@ -12403,7 +14102,7 @@
         </p:nvSpPr>
         <p:spPr>
           <a:xfrm>
-            <a:off x="1874519" y="4059936"/>
+            <a:off x="1874519" y="3666744"/>
             <a:ext cx="9418320" cy="365760"/>
           </a:xfrm>
           <a:prstGeom prst="rect">
@@ -12445,7 +14144,7 @@
         </p:nvSpPr>
         <p:spPr>
           <a:xfrm>
-            <a:off x="777240" y="4581144"/>
+            <a:off x="777240" y="4059936"/>
             <a:ext cx="1005840" cy="548640"/>
           </a:xfrm>
           <a:prstGeom prst="rect">
@@ -12487,7 +14186,7 @@
         </p:nvSpPr>
         <p:spPr>
           <a:xfrm>
-            <a:off x="1874519" y="4562856"/>
+            <a:off x="1874519" y="4041648"/>
             <a:ext cx="9418320" cy="411480"/>
           </a:xfrm>
           <a:prstGeom prst="rect">
@@ -12529,7 +14228,7 @@
         </p:nvSpPr>
         <p:spPr>
           <a:xfrm>
-            <a:off x="1874519" y="4992624"/>
+            <a:off x="1874519" y="4471416"/>
             <a:ext cx="9418320" cy="365760"/>
           </a:xfrm>
           <a:prstGeom prst="rect">
@@ -12571,7 +14270,7 @@
         </p:nvSpPr>
         <p:spPr>
           <a:xfrm>
-            <a:off x="777240" y="5513832"/>
+            <a:off x="777240" y="4864608"/>
             <a:ext cx="1005840" cy="548640"/>
           </a:xfrm>
           <a:prstGeom prst="rect">
@@ -12613,7 +14312,7 @@
         </p:nvSpPr>
         <p:spPr>
           <a:xfrm>
-            <a:off x="1874519" y="5495544"/>
+            <a:off x="1874519" y="4846320"/>
             <a:ext cx="9418320" cy="411480"/>
           </a:xfrm>
           <a:prstGeom prst="rect">
@@ -12655,7 +14354,7 @@
         </p:nvSpPr>
         <p:spPr>
           <a:xfrm>
-            <a:off x="1874519" y="5925312"/>
+            <a:off x="1874519" y="5276088"/>
             <a:ext cx="9418320" cy="365760"/>
           </a:xfrm>
           <a:prstGeom prst="rect">
@@ -12685,6 +14384,132 @@
                 <a:latin typeface="Poppins Light"/>
               </a:rPr>
               <a:t>Logistic regression · Brier skill · ROC/AUC · reliability</a:t>
+            </a:r>
+          </a:p>
+        </p:txBody>
+      </p:sp>
+      <p:sp>
+        <p:nvSpPr>
+          <p:cNvPr id="20" name="TextBox 19"/>
+          <p:cNvSpPr txBox="1"/>
+          <p:nvPr/>
+        </p:nvSpPr>
+        <p:spPr>
+          <a:xfrm>
+            <a:off x="777240" y="5669280"/>
+            <a:ext cx="1005840" cy="548640"/>
+          </a:xfrm>
+          <a:prstGeom prst="rect">
+            <a:avLst/>
+          </a:prstGeom>
+          <a:noFill/>
+        </p:spPr>
+        <p:txBody>
+          <a:bodyPr wrap="square" lIns="0" rIns="0" tIns="0" bIns="0" anchor="t">
+            <a:spAutoFit/>
+          </a:bodyPr>
+          <a:lstStyle/>
+          <a:p>
+            <a:pPr algn="l">
+              <a:lnSpc>
+                <a:spcPct val="112000"/>
+              </a:lnSpc>
+              <a:spcAft>
+                <a:spcPts val="0"/>
+              </a:spcAft>
+            </a:pPr>
+            <a:r>
+              <a:rPr sz="2600" b="0" i="0">
+                <a:solidFill>
+                  <a:srgbClr val="E08A3C"/>
+                </a:solidFill>
+                <a:latin typeface="Poppins Light"/>
+              </a:rPr>
+              <a:t>RQ6</a:t>
+            </a:r>
+          </a:p>
+        </p:txBody>
+      </p:sp>
+      <p:sp>
+        <p:nvSpPr>
+          <p:cNvPr id="21" name="TextBox 20"/>
+          <p:cNvSpPr txBox="1"/>
+          <p:nvPr/>
+        </p:nvSpPr>
+        <p:spPr>
+          <a:xfrm>
+            <a:off x="1874519" y="5650992"/>
+            <a:ext cx="9418320" cy="411480"/>
+          </a:xfrm>
+          <a:prstGeom prst="rect">
+            <a:avLst/>
+          </a:prstGeom>
+          <a:noFill/>
+        </p:spPr>
+        <p:txBody>
+          <a:bodyPr wrap="square" lIns="0" rIns="0" tIns="0" bIns="0" anchor="t">
+            <a:spAutoFit/>
+          </a:bodyPr>
+          <a:lstStyle/>
+          <a:p>
+            <a:pPr algn="l">
+              <a:lnSpc>
+                <a:spcPct val="112000"/>
+              </a:lnSpc>
+              <a:spcAft>
+                <a:spcPts val="0"/>
+              </a:spcAft>
+            </a:pPr>
+            <a:r>
+              <a:rPr sz="1900" b="0" i="0">
+                <a:solidFill>
+                  <a:srgbClr val="F2F2F2"/>
+                </a:solidFill>
+                <a:latin typeface="Poppins Light"/>
+              </a:rPr>
+              <a:t>Can baseline ML warn 1–3 days ahead, even in a city it never saw?</a:t>
+            </a:r>
+          </a:p>
+        </p:txBody>
+      </p:sp>
+      <p:sp>
+        <p:nvSpPr>
+          <p:cNvPr id="22" name="TextBox 21"/>
+          <p:cNvSpPr txBox="1"/>
+          <p:nvPr/>
+        </p:nvSpPr>
+        <p:spPr>
+          <a:xfrm>
+            <a:off x="1874519" y="6080760"/>
+            <a:ext cx="9418320" cy="365760"/>
+          </a:xfrm>
+          <a:prstGeom prst="rect">
+            <a:avLst/>
+          </a:prstGeom>
+          <a:noFill/>
+        </p:spPr>
+        <p:txBody>
+          <a:bodyPr wrap="square" lIns="0" rIns="0" tIns="0" bIns="0" anchor="t">
+            <a:spAutoFit/>
+          </a:bodyPr>
+          <a:lstStyle/>
+          <a:p>
+            <a:pPr algn="l">
+              <a:lnSpc>
+                <a:spcPct val="112000"/>
+              </a:lnSpc>
+              <a:spcAft>
+                <a:spcPts val="0"/>
+              </a:spcAft>
+            </a:pPr>
+            <a:r>
+              <a:rPr sz="1350" b="0" i="0">
+                <a:solidFill>
+                  <a:srgbClr val="A8A8A8"/>
+                </a:solidFill>
+                <a:latin typeface="Poppins Light"/>
+              </a:rPr>
+              <a:t>Decision tree · random forest · hybrid IMD + ML alert · leave-one-city-out</a:t>
             </a:r>
           </a:p>
         </p:txBody>

</xml_diff>